<commit_message>
Document E6 negative result and refresh competition materials
</commit_message>
<xml_diff>
--- a/docs/competition/slides/XA-202609_双向智能Boolean_Oracle答辩稿.pptx
+++ b/docs/competition/slides/XA-202609_双向智能Boolean_Oracle答辩稿.pptx
@@ -2,26 +2,26 @@
 <file path=ppt/presentation.xml><?xml version="1.0" encoding="utf-8"?>
 <p:presentation xmlns:p="http://schemas.openxmlformats.org/presentationml/2006/main">
   <p:sldMasterIdLst>
-    <p:sldMasterId xmlns:r="http://schemas.openxmlformats.org/officeDocument/2006/relationships" id="2147483648" r:id="Radff57a9b6c94e45"/>
+    <p:sldMasterId xmlns:r="http://schemas.openxmlformats.org/officeDocument/2006/relationships" id="2147483648" r:id="R0041fd5312b14536"/>
   </p:sldMasterIdLst>
   <p:notesMasterIdLst>
-    <p:notesMasterId xmlns:r="http://schemas.openxmlformats.org/officeDocument/2006/relationships" r:id="R09787c7f2d93452d"/>
+    <p:notesMasterId xmlns:r="http://schemas.openxmlformats.org/officeDocument/2006/relationships" r:id="R10353a50e3d64b69"/>
   </p:notesMasterIdLst>
   <p:sldIdLst>
-    <p:sldId xmlns:r="http://schemas.openxmlformats.org/officeDocument/2006/relationships" id="256" r:id="R484ce3aed49d4a59"/>
-    <p:sldId xmlns:r="http://schemas.openxmlformats.org/officeDocument/2006/relationships" id="257" r:id="R2ce9f0fbd3184c54"/>
-    <p:sldId xmlns:r="http://schemas.openxmlformats.org/officeDocument/2006/relationships" id="258" r:id="Rfa4758e586714ea2"/>
-    <p:sldId xmlns:r="http://schemas.openxmlformats.org/officeDocument/2006/relationships" id="259" r:id="R6b59bace2e7b4c48"/>
-    <p:sldId xmlns:r="http://schemas.openxmlformats.org/officeDocument/2006/relationships" id="260" r:id="R11a43a30493c4844"/>
-    <p:sldId xmlns:r="http://schemas.openxmlformats.org/officeDocument/2006/relationships" id="261" r:id="Rbf14398623074be7"/>
-    <p:sldId xmlns:r="http://schemas.openxmlformats.org/officeDocument/2006/relationships" id="262" r:id="R2b643efecb074bbb"/>
-    <p:sldId xmlns:r="http://schemas.openxmlformats.org/officeDocument/2006/relationships" id="263" r:id="R2372615d29b14087"/>
-    <p:sldId xmlns:r="http://schemas.openxmlformats.org/officeDocument/2006/relationships" id="264" r:id="Rfbc39fe7d7454f7a"/>
-    <p:sldId xmlns:r="http://schemas.openxmlformats.org/officeDocument/2006/relationships" id="265" r:id="R7f179bee5a4b4653"/>
-    <p:sldId xmlns:r="http://schemas.openxmlformats.org/officeDocument/2006/relationships" id="266" r:id="Rd1238c100d344f37"/>
-    <p:sldId xmlns:r="http://schemas.openxmlformats.org/officeDocument/2006/relationships" id="267" r:id="Ra8365393a1a84ff2"/>
-    <p:sldId xmlns:r="http://schemas.openxmlformats.org/officeDocument/2006/relationships" id="268" r:id="Rfa13a64ebf514fc9"/>
-    <p:sldId xmlns:r="http://schemas.openxmlformats.org/officeDocument/2006/relationships" id="269" r:id="R8509b85dfab64520"/>
+    <p:sldId xmlns:r="http://schemas.openxmlformats.org/officeDocument/2006/relationships" id="256" r:id="R9590c31d368741ec"/>
+    <p:sldId xmlns:r="http://schemas.openxmlformats.org/officeDocument/2006/relationships" id="257" r:id="R4fcfcd3336f241f6"/>
+    <p:sldId xmlns:r="http://schemas.openxmlformats.org/officeDocument/2006/relationships" id="258" r:id="Rb3b18648cfe046ed"/>
+    <p:sldId xmlns:r="http://schemas.openxmlformats.org/officeDocument/2006/relationships" id="259" r:id="Rb99898c2dc9e4ea4"/>
+    <p:sldId xmlns:r="http://schemas.openxmlformats.org/officeDocument/2006/relationships" id="260" r:id="R446399b796084182"/>
+    <p:sldId xmlns:r="http://schemas.openxmlformats.org/officeDocument/2006/relationships" id="261" r:id="R7b56d3327ddb43b6"/>
+    <p:sldId xmlns:r="http://schemas.openxmlformats.org/officeDocument/2006/relationships" id="262" r:id="Rdd7d9e5a10fe4b49"/>
+    <p:sldId xmlns:r="http://schemas.openxmlformats.org/officeDocument/2006/relationships" id="263" r:id="Rc17c11094a02423a"/>
+    <p:sldId xmlns:r="http://schemas.openxmlformats.org/officeDocument/2006/relationships" id="264" r:id="Re68c4f5fb0334491"/>
+    <p:sldId xmlns:r="http://schemas.openxmlformats.org/officeDocument/2006/relationships" id="265" r:id="R2e70a6405ebf45e9"/>
+    <p:sldId xmlns:r="http://schemas.openxmlformats.org/officeDocument/2006/relationships" id="266" r:id="R250da6dc15ee4044"/>
+    <p:sldId xmlns:r="http://schemas.openxmlformats.org/officeDocument/2006/relationships" id="267" r:id="R9b29081a494f4470"/>
+    <p:sldId xmlns:r="http://schemas.openxmlformats.org/officeDocument/2006/relationships" id="268" r:id="R2316df0d76b94313"/>
+    <p:sldId xmlns:r="http://schemas.openxmlformats.org/officeDocument/2006/relationships" id="269" r:id="R64dbc03e7a0f4e1f"/>
   </p:sldIdLst>
   <p:sldSz cx="12192000" cy="6858000"/>
   <p:notesSz cx="6858000" cy="9144000"/>
@@ -854,7 +854,7 @@
           </a:p>
           <a:p xmlns:a="http://schemas.openxmlformats.org/drawingml/2006/main">
             <a:r>
-              <a:t>当前集成树回归为 407 passed in 334.05s；legacy smoke 为 smoke ok。</a:t>
+              <a:t>当前集成树完整回归为 588 passed in 363.66s；legacy smoke 为 smoke ok。</a:t>
             </a:r>
             <a:endParaRPr/>
           </a:p>
@@ -866,61 +866,61 @@
           </a:p>
           <a:p xmlns:a="http://schemas.openxmlformats.org/drawingml/2006/main">
             <a:r>
-              <a:t>交付外层检查记录 E4-v2 calibration 26/26、replication 32/32，E5 V3 current/fresh 20/20、fresh-v2 19/19；这些数字只表示证据链检查通过，不是性能成功率。</a:t>
+              <a:t>E6 五文件 full bundle 绑定 clean source e850c0c；固定语料、初始化和 seed 下四臂依次训练，独立 verifier 确定性重训并以 11/11 通过。该检查只闭合开发机制与复现，不是性能成功率。</a:t>
             </a:r>
             <a:endParaRPr/>
           </a:p>
           <a:p xmlns:a="http://schemas.openxmlformats.org/drawingml/2006/main">
             <a:r>
-              <a:t>E4-v2 calibration 只使用 12 个非 AES 函数和 72 个候选记录；replication 是 AES 已见坐标上的 64 条 post-E4 四臂复验。E5 portable V3 与 fresh-v2 只闭合跨 build 软件验证，仍明确 protocol_acceptance=false、experiment_completed=false，没有 accepted endpoint。</a:t>
+              <a:t>当前 38 页唯一中文主稿已同步 Overleaf origin/main 739b6c921e5c574871b12172024e2302aed8bb9c；本地 PDF SHA-256 为 fadd6965e39a390589086e1784e6e68984ce2121339dbace802775858d3fcfe3。</a:t>
             </a:r>
             <a:endParaRPr/>
           </a:p>
           <a:p xmlns:a="http://schemas.openxmlformats.org/drawingml/2006/main">
             <a:r>
-              <a:t>35 页唯一中文主稿已同步 Overleaf origin/main c5c6993d1589469a61dfe18000a313d798b1c02f；本地 PDF SHA-256 为 f6a19cf8a7d2e245505777838a934f30219b378a063703784bf6cf535f908d8f。</a:t>
+              <a:t>E4-v2 与 E5 历史证据边界不变；所有执行证据仍为 synthetic profile，formal/performance/generalization/hardware/advantage 均为 false。</a:t>
             </a:r>
             <a:endParaRPr/>
           </a:p>
           <a:p xmlns:a="http://schemas.openxmlformats.org/drawingml/2006/main">
             <a:r>
-              <a:t>所有执行证据仍为 synthetic profile，hardware=false；无真机、量子加速或量子优势主张。</a:t>
+              <a:t>[Sources]</a:t>
             </a:r>
             <a:endParaRPr/>
           </a:p>
           <a:p xmlns:a="http://schemas.openxmlformats.org/drawingml/2006/main">
             <a:r>
-              <a:t>[Sources]</a:t>
+              <a:t>- docs/contracts/COMPETITION_ACCEPTANCE_MATRIX.json</a:t>
             </a:r>
             <a:endParaRPr/>
           </a:p>
           <a:p xmlns:a="http://schemas.openxmlformats.org/drawingml/2006/main">
             <a:r>
-              <a:t>- docs/contracts/COMPETITION_ACCEPTANCE_MATRIX.json</a:t>
+              <a:t>- experiments/results/xa202609/20260812-e5-v11-portable-fresh-validation-v2-s970000/verifier.json</a:t>
             </a:r>
             <a:endParaRPr/>
           </a:p>
           <a:p xmlns:a="http://schemas.openxmlformats.org/drawingml/2006/main">
             <a:r>
-              <a:t>- experiments/results/xa202609/20260812-e4-v2-frozen-replication-v1-s530000-cal/verifier.json</a:t>
+              <a:t>- experiments/results/xa202609/20260812-e6-q4ai-causal-v1-full-s20260912/results.json</a:t>
             </a:r>
             <a:endParaRPr/>
           </a:p>
           <a:p xmlns:a="http://schemas.openxmlformats.org/drawingml/2006/main">
             <a:r>
-              <a:t>- experiments/results/xa202609/20260812-e4-v2-frozen-replication-v1-s530000-test/verifier.json</a:t>
+              <a:t>- experiments/results/xa202609/20260812-e6-q4ai-causal-v1-full-s20260912/heldout_evaluation.json</a:t>
             </a:r>
             <a:endParaRPr/>
           </a:p>
           <a:p xmlns:a="http://schemas.openxmlformats.org/drawingml/2006/main">
             <a:r>
-              <a:t>- experiments/results/xa202609/20260812-e5-v11-portable-negative-audit-v3-s950000/verifier.json</a:t>
+              <a:t>- experiments/scripts/verify_e6_replay_training_bundle_v1.py</a:t>
             </a:r>
             <a:endParaRPr/>
           </a:p>
           <a:p xmlns:a="http://schemas.openxmlformats.org/drawingml/2006/main">
             <a:r>
-              <a:t>- experiments/results/xa202609/20260812-e5-v11-portable-fresh-validation-v2-s970000/verifier.json</a:t>
+              <a:t>- docs/competition/evidence/E6_Q4AI_CAUSAL_NEGATIVE_EVIDENCE.md</a:t>
             </a:r>
             <a:endParaRPr/>
           </a:p>
@@ -932,13 +932,13 @@
           </a:p>
           <a:p xmlns:a="http://schemas.openxmlformats.org/drawingml/2006/main">
             <a:r>
-              <a:t>- docs/papers/resource_nmcts/overleaf/worktree (origin/main c5c6993d1589469a61dfe18000a313d798b1c02f)</a:t>
+              <a:t>- docs/papers/resource_nmcts/overleaf/worktree (origin/main 739b6c921e5c574871b12172024e2302aed8bb9c)</a:t>
             </a:r>
             <a:endParaRPr/>
           </a:p>
           <a:p xmlns:a="http://schemas.openxmlformats.org/drawingml/2006/main">
             <a:r>
-              <a:t>- docs/papers/resource_nmcts/chinese/resource_nmcts_competition_current.pdf (SHA-256 f6a19cf8a7d2e245505777838a934f30219b378a063703784bf6cf535f908d8f)</a:t>
+              <a:t>- docs/papers/resource_nmcts/chinese/resource_nmcts_competition_current.pdf (SHA-256 fadd6965e39a390589086e1784e6e68984ce2121339dbace802775858d3fcfe3)</a:t>
             </a:r>
             <a:endParaRPr/>
           </a:p>
@@ -1009,37 +1009,55 @@
           <a:lstStyle xmlns:a="http://schemas.openxmlformats.org/drawingml/2006/main"/>
           <a:p xmlns:a="http://schemas.openxmlformats.org/drawingml/2006/main">
             <a:r>
-              <a:t>已闭合的贡献是：等变 policy 的结构先验、同池同预算 QAOA 的局部调度证据，以及独立验证器对语义/执行主张的约束。</a:t>
+              <a:t>E6 已实际运行 shared head、replay、trainer 与 exact scheduler 的四臂 development 机制消融，不再是尚未接入。</a:t>
             </a:r>
             <a:endParaRPr/>
           </a:p>
           <a:p xmlns:a="http://schemas.openxmlformats.org/drawingml/2006/main">
             <a:r>
-              <a:t>E4-v2 和 E5 表明端点改善并未验收：前者区间跨 0，后者协议验收失败。</a:t>
+              <a:t>主比较 QAOA final-measurement replay 减 permuted-label control 的下优资源比差为 +0.0949778，95% CI [0.0696384,0.1237673]，双侧 sign-flip p=9.9999e-6，W/T/L=0/3/29；n4/n5 分层均为正，claim_supported=false。</a:t>
             </a:r>
             <a:endParaRPr/>
           </a:p>
           <a:p xmlns:a="http://schemas.openxmlformats.org/drawingml/2006/main">
             <a:r>
-              <a:t>E6-MSO 是下一个可证伪问题：跨输出共享表达与同池 QAOA，但当前仅有 mechanism MVP。output-permutation-equivariant shared head、QAOA replay 和锁后未见 S-box formal bundle 都未完成。</a:t>
+              <a:t>QAOA 与 random 的 32/32 endpoint 相同，且两臂各有 31/32 空选择。固定设计下，当前 teacher 标签与下游资源目标错位；不能把单个置换标签 control 的胜出外推为置换标签普遍更好。</a:t>
             </a:r>
             <a:endParaRPr/>
           </a:p>
           <a:p xmlns:a="http://schemas.openxmlformats.org/drawingml/2006/main">
             <a:r>
-              <a:t>这里的资源计数仅指 abstract logical X/CNOT/MCT proxy，不是分解后或硬件精确门数。</a:t>
+              <a:t>D1 只诊断 replay 标签、head top-K 与 exact scheduler 的作用，不使用当前 heldout 选择模型或追逐正结果。</a:t>
             </a:r>
             <a:endParaRPr/>
           </a:p>
           <a:p xmlns:a="http://schemas.openxmlformats.org/drawingml/2006/main">
             <a:r>
-              <a:t>598→581 不是正式性能证据；不主张真机结果、量子加速或量子优势。</a:t>
+              <a:t>这里的 workspace peak≤2 和资源比只指 abstract logical X/CNOT/MCT proxy；MCT 分解未计，不是硬件精确门数。formal/performance/generalization/hardware/advantage 均为 false。</a:t>
             </a:r>
             <a:endParaRPr/>
           </a:p>
           <a:p xmlns:a="http://schemas.openxmlformats.org/drawingml/2006/main">
             <a:r>
               <a:t>[Sources]</a:t>
+            </a:r>
+            <a:endParaRPr/>
+          </a:p>
+          <a:p xmlns:a="http://schemas.openxmlformats.org/drawingml/2006/main">
+            <a:r>
+              <a:t>- docs/competition/evidence/E6_Q4AI_CAUSAL_NEGATIVE_EVIDENCE.md</a:t>
+            </a:r>
+            <a:endParaRPr/>
+          </a:p>
+          <a:p xmlns:a="http://schemas.openxmlformats.org/drawingml/2006/main">
+            <a:r>
+              <a:t>- experiments/results/xa202609/20260812-e6-q4ai-causal-v1-full-s20260912/results.json</a:t>
+            </a:r>
+            <a:endParaRPr/>
+          </a:p>
+          <a:p xmlns:a="http://schemas.openxmlformats.org/drawingml/2006/main">
+            <a:r>
+              <a:t>- experiments/results/xa202609/20260812-e6-q4ai-causal-v1-full-s20260912/heldout_evaluation.json</a:t>
             </a:r>
             <a:endParaRPr/>
           </a:p>
@@ -1134,25 +1152,37 @@
           <a:lstStyle xmlns:a="http://schemas.openxmlformats.org/drawingml/2006/main"/>
           <a:p xmlns:a="http://schemas.openxmlformats.org/drawingml/2006/main">
             <a:r>
-              <a:t>收束：双向赋能不是把 AI 与 QAOA 并列堆叠，而是让二者在同一搜索预算接口上接受语义和端点检验。</a:t>
+              <a:t>收束：AI4Q 与 Q4AI 已在同一开发链中贯通，四臂实验给出显著反向而不是期望中的改善。</a:t>
             </a:r>
             <a:endParaRPr/>
           </a:p>
           <a:p xmlns:a="http://schemas.openxmlformats.org/drawingml/2006/main">
             <a:r>
-              <a:t>当前证据支持局部机制，也通过 E4-v2 跨零区间和 E5 协议失败明确终止过度主张。</a:t>
+              <a:t>固定条件下，当前 QAOA teacher 标签关联对资源目标有害；这不是量子优势、性能、泛化、formal 或硬件证据。</a:t>
             </a:r>
             <a:endParaRPr/>
           </a:p>
           <a:p xmlns:a="http://schemas.openxmlformats.org/drawingml/2006/main">
             <a:r>
-              <a:t>下一研究门是 E6-MSO，必须在 shared head、QAOA replay 与锁后 formal blind result 全部就位后才升级性能主张。</a:t>
+              <a:t>下一步直接做 D1 机制诊断，拆解 replay 标签、head top-K 与 exact scheduler；不在当前 heldout 事后调参。</a:t>
             </a:r>
             <a:endParaRPr/>
           </a:p>
           <a:p xmlns:a="http://schemas.openxmlformats.org/drawingml/2006/main">
             <a:r>
               <a:t>[Sources]</a:t>
+            </a:r>
+            <a:endParaRPr/>
+          </a:p>
+          <a:p xmlns:a="http://schemas.openxmlformats.org/drawingml/2006/main">
+            <a:r>
+              <a:t>- docs/competition/evidence/E6_Q4AI_CAUSAL_NEGATIVE_EVIDENCE.md</a:t>
+            </a:r>
+            <a:endParaRPr/>
+          </a:p>
+          <a:p xmlns:a="http://schemas.openxmlformats.org/drawingml/2006/main">
+            <a:r>
+              <a:t>- experiments/results/xa202609/20260812-e6-q4ai-causal-v1-full-s20260912/results.json</a:t>
             </a:r>
             <a:endParaRPr/>
           </a:p>
@@ -4894,17 +4924,17 @@
   </p:cSld>
   <p:clrMap bg1="lt1" tx1="dk1" bg2="lt2" tx2="dk2" accent1="accent1" accent2="accent2" accent3="accent3" accent4="accent4" accent5="accent5" accent6="accent6" hlink="hlink" folHlink="folHlink"/>
   <p:sldLayoutIdLst>
-    <p:sldLayoutId xmlns:r="http://schemas.openxmlformats.org/officeDocument/2006/relationships" id="2147483649" r:id="R36415f1b17464997"/>
-    <p:sldLayoutId xmlns:r="http://schemas.openxmlformats.org/officeDocument/2006/relationships" id="2147483650" r:id="Rd6a8d64547804fed"/>
-    <p:sldLayoutId xmlns:r="http://schemas.openxmlformats.org/officeDocument/2006/relationships" id="2147483651" r:id="R07cd5547008f40c1"/>
-    <p:sldLayoutId xmlns:r="http://schemas.openxmlformats.org/officeDocument/2006/relationships" id="2147483652" r:id="Rd48dcb663f2d429e"/>
-    <p:sldLayoutId xmlns:r="http://schemas.openxmlformats.org/officeDocument/2006/relationships" id="2147483653" r:id="Rc86bcff6bd974a07"/>
-    <p:sldLayoutId xmlns:r="http://schemas.openxmlformats.org/officeDocument/2006/relationships" id="2147483654" r:id="Rd701c2ce861d4bf3"/>
-    <p:sldLayoutId xmlns:r="http://schemas.openxmlformats.org/officeDocument/2006/relationships" id="2147483655" r:id="Re196f0939cff451b"/>
-    <p:sldLayoutId xmlns:r="http://schemas.openxmlformats.org/officeDocument/2006/relationships" id="2147483656" r:id="R214048f6a4ce4fa5"/>
-    <p:sldLayoutId xmlns:r="http://schemas.openxmlformats.org/officeDocument/2006/relationships" id="2147483657" r:id="R7bd0f744d1834010"/>
-    <p:sldLayoutId xmlns:r="http://schemas.openxmlformats.org/officeDocument/2006/relationships" id="2147483658" r:id="R4d68a894e01b43bd"/>
-    <p:sldLayoutId xmlns:r="http://schemas.openxmlformats.org/officeDocument/2006/relationships" id="2147483659" r:id="Rf1a0b6568e164fc9"/>
+    <p:sldLayoutId xmlns:r="http://schemas.openxmlformats.org/officeDocument/2006/relationships" id="2147483649" r:id="R89e0a361beb443a1"/>
+    <p:sldLayoutId xmlns:r="http://schemas.openxmlformats.org/officeDocument/2006/relationships" id="2147483650" r:id="R2dccb318e6734aca"/>
+    <p:sldLayoutId xmlns:r="http://schemas.openxmlformats.org/officeDocument/2006/relationships" id="2147483651" r:id="Rbd14a3e21f054617"/>
+    <p:sldLayoutId xmlns:r="http://schemas.openxmlformats.org/officeDocument/2006/relationships" id="2147483652" r:id="R64ad71240b564115"/>
+    <p:sldLayoutId xmlns:r="http://schemas.openxmlformats.org/officeDocument/2006/relationships" id="2147483653" r:id="R532d60fca29348b2"/>
+    <p:sldLayoutId xmlns:r="http://schemas.openxmlformats.org/officeDocument/2006/relationships" id="2147483654" r:id="R676a8f9165ee4b3d"/>
+    <p:sldLayoutId xmlns:r="http://schemas.openxmlformats.org/officeDocument/2006/relationships" id="2147483655" r:id="Re80a02e3f1ee44a5"/>
+    <p:sldLayoutId xmlns:r="http://schemas.openxmlformats.org/officeDocument/2006/relationships" id="2147483656" r:id="Rdb28332c94834514"/>
+    <p:sldLayoutId xmlns:r="http://schemas.openxmlformats.org/officeDocument/2006/relationships" id="2147483657" r:id="Rb86bbb0334384aa1"/>
+    <p:sldLayoutId xmlns:r="http://schemas.openxmlformats.org/officeDocument/2006/relationships" id="2147483658" r:id="Ra1bfda86c6284f23"/>
+    <p:sldLayoutId xmlns:r="http://schemas.openxmlformats.org/officeDocument/2006/relationships" id="2147483659" r:id="Rf10455007d894e34"/>
   </p:sldLayoutIdLst>
   <p:txStyles>
     <p:titleStyle>
@@ -6734,7 +6764,7 @@
           <p:nvPr/>
         </p:nvPicPr>
         <p:blipFill>
-          <a:blip xmlns:r="http://schemas.openxmlformats.org/officeDocument/2006/relationships" xmlns:a="http://schemas.openxmlformats.org/drawingml/2006/main" r:embed="Rd4a0bf6540fa4819"/>
+          <a:blip xmlns:r="http://schemas.openxmlformats.org/officeDocument/2006/relationships" xmlns:a="http://schemas.openxmlformats.org/drawingml/2006/main" r:embed="Ra561820502514a77"/>
           <a:stretch xmlns:a="http://schemas.openxmlformats.org/drawingml/2006/main">
             <a:fillRect l="0" t="0" r="0" b="0"/>
           </a:stretch>
@@ -6897,7 +6927,7 @@
           <p:nvPr/>
         </p:nvPicPr>
         <p:blipFill>
-          <a:blip xmlns:r="http://schemas.openxmlformats.org/officeDocument/2006/relationships" xmlns:a="http://schemas.openxmlformats.org/drawingml/2006/main" r:embed="Ra4b86db36b6c4c77"/>
+          <a:blip xmlns:r="http://schemas.openxmlformats.org/officeDocument/2006/relationships" xmlns:a="http://schemas.openxmlformats.org/drawingml/2006/main" r:embed="Rabc7b2b03977459c"/>
           <a:srcRect xmlns:a="http://schemas.openxmlformats.org/drawingml/2006/main" l="0" t="0" r="0" b="0"/>
           <a:stretch xmlns:a="http://schemas.openxmlformats.org/drawingml/2006/main">
             <a:fillRect l="0" t="0" r="0" b="0"/>
@@ -7019,7 +7049,7 @@
           <p:nvPr/>
         </p:nvPicPr>
         <p:blipFill>
-          <a:blip xmlns:r="http://schemas.openxmlformats.org/officeDocument/2006/relationships" xmlns:a="http://schemas.openxmlformats.org/drawingml/2006/main" r:embed="R7efe482fe65c42ba"/>
+          <a:blip xmlns:r="http://schemas.openxmlformats.org/officeDocument/2006/relationships" xmlns:a="http://schemas.openxmlformats.org/drawingml/2006/main" r:embed="Radb635589df0414a"/>
           <a:stretch xmlns:a="http://schemas.openxmlformats.org/drawingml/2006/main">
             <a:fillRect l="0" t="0" r="0" b="0"/>
           </a:stretch>
@@ -7696,7 +7726,7 @@
         </p:xfrm>
         <a:graphic xmlns:a="http://schemas.openxmlformats.org/drawingml/2006/main">
           <a:graphicData uri="http://schemas.openxmlformats.org/drawingml/2006/chart">
-            <c:chart xmlns:r="http://schemas.openxmlformats.org/officeDocument/2006/relationships" xmlns:c="http://schemas.openxmlformats.org/drawingml/2006/chart" r:id="Rfd543581f21340d8"/>
+            <c:chart xmlns:r="http://schemas.openxmlformats.org/officeDocument/2006/relationships" xmlns:c="http://schemas.openxmlformats.org/drawingml/2006/chart" r:id="R4b51629cc80042c8"/>
           </a:graphicData>
         </a:graphic>
       </p:graphicFrame>
@@ -7806,7 +7836,7 @@
           <p:nvPr/>
         </p:nvPicPr>
         <p:blipFill>
-          <a:blip xmlns:r="http://schemas.openxmlformats.org/officeDocument/2006/relationships" xmlns:a="http://schemas.openxmlformats.org/drawingml/2006/main" r:embed="R9a53788d03d247af"/>
+          <a:blip xmlns:r="http://schemas.openxmlformats.org/officeDocument/2006/relationships" xmlns:a="http://schemas.openxmlformats.org/drawingml/2006/main" r:embed="Rc0c16e93d1de435f"/>
           <a:stretch xmlns:a="http://schemas.openxmlformats.org/drawingml/2006/main">
             <a:fillRect l="0" t="0" r="0" b="0"/>
           </a:stretch>
@@ -8433,7 +8463,7 @@
         </p:xfrm>
         <a:graphic xmlns:a="http://schemas.openxmlformats.org/drawingml/2006/main">
           <a:graphicData uri="http://schemas.openxmlformats.org/drawingml/2006/chart">
-            <c:chart xmlns:r="http://schemas.openxmlformats.org/officeDocument/2006/relationships" xmlns:c="http://schemas.openxmlformats.org/drawingml/2006/chart" r:id="Re4fdb68fdac44e27"/>
+            <c:chart xmlns:r="http://schemas.openxmlformats.org/officeDocument/2006/relationships" xmlns:c="http://schemas.openxmlformats.org/drawingml/2006/chart" r:id="R4b37481918c34ba6"/>
           </a:graphicData>
         </a:graphic>
       </p:graphicFrame>
@@ -8442,7 +8472,7 @@
           <p:cNvPr id="40" name="E4-v2 statistical boundary">
             <a:extLst xmlns:a="http://schemas.openxmlformats.org/drawingml/2006/main">
               <a:ext uri="{FF2B5EF4-FFF2-40B4-BE49-F238E27FC236}">
-                <a16:creationId xmlns:a16="http://schemas.microsoft.com/office/drawing/2014/main" id="{663EA2B4-C1D9-4314-A19A-81DC26AE3CA7}"/>
+                <a16:creationId xmlns:a16="http://schemas.microsoft.com/office/drawing/2014/main" id="{FDCA801D-1485-41A5-95D3-F94F08C66CBD}"/>
               </a:ext>
             </a:extLst>
           </p:cNvPr>
@@ -9024,7 +9054,7 @@
           <p:nvPr/>
         </p:nvPicPr>
         <p:blipFill>
-          <a:blip xmlns:r="http://schemas.openxmlformats.org/officeDocument/2006/relationships" xmlns:a="http://schemas.openxmlformats.org/drawingml/2006/main" r:embed="R522cada8b8634ff4"/>
+          <a:blip xmlns:r="http://schemas.openxmlformats.org/officeDocument/2006/relationships" xmlns:a="http://schemas.openxmlformats.org/drawingml/2006/main" r:embed="R68510c1603bd4b89"/>
           <a:stretch xmlns:a="http://schemas.openxmlformats.org/drawingml/2006/main">
             <a:fillRect l="0" t="0" r="0" b="0"/>
           </a:stretch>
@@ -9211,7 +9241,7 @@
           <p:nvPr/>
         </p:nvPicPr>
         <p:blipFill>
-          <a:blip xmlns:r="http://schemas.openxmlformats.org/officeDocument/2006/relationships" xmlns:a="http://schemas.openxmlformats.org/drawingml/2006/main" r:embed="R2de5db92788f4713"/>
+          <a:blip xmlns:r="http://schemas.openxmlformats.org/officeDocument/2006/relationships" xmlns:a="http://schemas.openxmlformats.org/drawingml/2006/main" r:embed="R19898a5d96954e38"/>
           <a:srcRect xmlns:a="http://schemas.openxmlformats.org/drawingml/2006/main" l="0" t="0" r="0" b="0"/>
           <a:stretch xmlns:a="http://schemas.openxmlformats.org/drawingml/2006/main">
             <a:fillRect l="0" t="0" r="0" b="0"/>
@@ -9277,7 +9307,7 @@
                 <a:ea typeface="微软雅黑"/>
                 <a:cs typeface="微软雅黑"/>
               </a:rPr>
-              <a:t>● 407 tests + smoke ok｜E4-v2 external：cal 26/26、rep 32/32</a:t>
+              <a:t>● 588 tests + smoke ok｜E6 四臂 development 已闭合；语义全过、fallback=0、verifier 11/11</a:t>
             </a:r>
             <a:endParaRPr sz="2400" b="1">
               <a:solidFill>
@@ -9306,7 +9336,7 @@
                 <a:ea typeface="微软雅黑"/>
                 <a:cs typeface="微软雅黑"/>
               </a:rPr>
-              <a:t>● E5 V3 current/fresh 20/20；fresh-v2 19/19；protocol=false｜35 页中文主稿已同步 Overleaf｜hardware=false</a:t>
+              <a:t>● 38 页中文主稿已同步 Overleaf｜claim/formal/performance/generalization/hardware=false</a:t>
             </a:r>
             <a:endParaRPr sz="2400" b="1">
               <a:solidFill>
@@ -9380,7 +9410,7 @@
                 <a:ea typeface="微软雅黑"/>
                 <a:cs typeface="微软雅黑"/>
               </a:rPr>
-              <a:t>E4-v2 26/26 + 32/32</a:t>
+              <a:t>E6 full bundle｜verifier 11/11</a:t>
             </a:r>
             <a:endParaRPr b="1">
               <a:solidFill>
@@ -9410,7 +9440,7 @@
                 <a:ea typeface="微软雅黑"/>
                 <a:cs typeface="微软雅黑"/>
               </a:rPr>
-              <a:t>E5 V3 20/20｜fresh-v2 19/19｜protocol=false</a:t>
+              <a:t>formal/performance/hardware=false</a:t>
             </a:r>
             <a:endParaRPr b="1">
               <a:solidFill>
@@ -9432,7 +9462,7 @@
           <p:nvPr/>
         </p:nvPicPr>
         <p:blipFill>
-          <a:blip xmlns:r="http://schemas.openxmlformats.org/officeDocument/2006/relationships" xmlns:a="http://schemas.openxmlformats.org/drawingml/2006/main" r:embed="Rbb3d167758f74aa2"/>
+          <a:blip xmlns:r="http://schemas.openxmlformats.org/officeDocument/2006/relationships" xmlns:a="http://schemas.openxmlformats.org/drawingml/2006/main" r:embed="Rf8a6ed6c4c554d78"/>
           <a:srcRect xmlns:a="http://schemas.openxmlformats.org/drawingml/2006/main" l="0" t="0" r="0" b="0"/>
           <a:stretch xmlns:a="http://schemas.openxmlformats.org/drawingml/2006/main">
             <a:fillRect l="0" t="0" r="0" b="0"/>
@@ -9554,7 +9584,7 @@
           <p:nvPr/>
         </p:nvPicPr>
         <p:blipFill>
-          <a:blip xmlns:r="http://schemas.openxmlformats.org/officeDocument/2006/relationships" xmlns:a="http://schemas.openxmlformats.org/drawingml/2006/main" r:embed="R80ea6f14d560401d"/>
+          <a:blip xmlns:r="http://schemas.openxmlformats.org/officeDocument/2006/relationships" xmlns:a="http://schemas.openxmlformats.org/drawingml/2006/main" r:embed="R226d2436a8ca4566"/>
           <a:stretch xmlns:a="http://schemas.openxmlformats.org/drawingml/2006/main">
             <a:fillRect l="0" t="0" r="0" b="0"/>
           </a:stretch>
@@ -9627,7 +9657,7 @@
                 <a:ea typeface="黑体"/>
                 <a:cs typeface="黑体"/>
               </a:rPr>
-              <a:t>下一研究门是 E6-MSO</a:t>
+              <a:t>E6：反向结果指向 D1 诊断</a:t>
             </a:r>
             <a:endParaRPr sz="4800" b="1">
               <a:ln w="10160">
@@ -9781,7 +9811,7 @@
                 <a:ea typeface="微软雅黑"/>
                 <a:cs typeface="微软雅黑"/>
               </a:rPr>
-              <a:t>AI4Q｜置换等变 policy + 可验证 Neural MCTS</a:t>
+              <a:t>AI4Q｜shared head → replay → trainer 已贯通；64 train + 32 whole-vector development，语义全过、0 fallback。</a:t>
             </a:r>
             <a:endParaRPr sz="2400" b="1">
               <a:solidFill>
@@ -9801,7 +9831,7 @@
             </a:pPr>
             <a:r>
               <a:rPr sz="1425"/>
-              <a:t>把 Boolean 对称性写入结构先验；formal v4 只闭合 provenance，性能仍未验收。</a:t>
+              <a:t>Q4AI｜固定条件下，当前 teacher 标签关联显著有害。</a:t>
             </a:r>
             <a:endParaRPr sz="2400" b="1">
               <a:solidFill>
@@ -9820,14 +9850,14 @@
               <a:buNone/>
             </a:pPr>
             <a:r>
-              <a:rPr sz="2400" b="1">
+              <a:rPr sz="1425" b="1">
                 <a:solidFill>
                   <a:schemeClr val="accent6">
                     <a:lumMod val="75000"/>
                   </a:schemeClr>
                 </a:solidFill>
               </a:rPr>
-              <a:t/>
+              <a:t>资源比差（QAOA−置换标签）=+0.094978（越低越好）</a:t>
             </a:r>
             <a:endParaRPr sz="2400" b="1">
               <a:latin typeface="微软雅黑"/>
@@ -9844,7 +9874,7 @@
             </a:pPr>
             <a:r>
               <a:rPr sz="1425"/>
-              <a:t>Q4AI｜同池 QAOA + execution-aware utility</a:t>
+              <a:t>95% CI [0.069638,0.123767]｜p=9.9999e-6｜W/T/L=0/3/29</a:t>
             </a:r>
             <a:endParaRPr sz="2400" b="1">
               <a:solidFill>
@@ -9869,7 +9899,7 @@
                   </a:schemeClr>
                 </a:solidFill>
               </a:rPr>
-              <a:t>E2/E4 支持局部选择；E4-v2 CI 跨 0，E5 无 accepted endpoint。</a:t>
+              <a:t>QAOA/random：32/32 endpoint 相同，均有 31/32 空选择。</a:t>
             </a:r>
             <a:endParaRPr sz="2400" b="1">
               <a:solidFill>
@@ -9887,7 +9917,8 @@
               <a:buNone/>
             </a:pPr>
             <a:r>
-              <a:t/>
+              <a:rPr sz="1425"/>
+              <a:t>D1｜拆解 replay 标签 → head top-K → exact scheduler；不在当前 heldout 事后调参。</a:t>
             </a:r>
             <a:endParaRPr sz="2400" b="1">
               <a:solidFill>
@@ -9909,51 +9940,7 @@
             </a:pPr>
             <a:r>
               <a:rPr sz="1425"/>
-              <a:t>NEXT｜E6-MSO 多输出共享表达式</a:t>
-            </a:r>
-            <a:endParaRPr sz="2400" b="1">
-              <a:solidFill>
-                <a:schemeClr val="accent6">
-                  <a:lumMod val="75000"/>
-                </a:schemeClr>
-              </a:solidFill>
-              <a:latin typeface="微软雅黑"/>
-              <a:ea typeface="微软雅黑"/>
-              <a:cs typeface="微软雅黑"/>
-            </a:endParaRPr>
-          </a:p>
-          <a:p xmlns:a="http://schemas.openxmlformats.org/drawingml/2006/main">
-            <a:pPr algn="just">
-              <a:lnSpc>
-                <a:spcPct val="160000"/>
-              </a:lnSpc>
-              <a:buNone/>
-            </a:pPr>
-            <a:r>
-              <a:rPr sz="1425"/>
-              <a:t>VectorANF + shared action + compute–fanout–uncompute；显式 workspace peak≤2（MCT 分解未计）。</a:t>
-            </a:r>
-            <a:endParaRPr sz="2400" b="1">
-              <a:solidFill>
-                <a:schemeClr val="accent6">
-                  <a:lumMod val="75000"/>
-                </a:schemeClr>
-              </a:solidFill>
-              <a:latin typeface="微软雅黑"/>
-              <a:ea typeface="微软雅黑"/>
-              <a:cs typeface="微软雅黑"/>
-            </a:endParaRPr>
-          </a:p>
-          <a:p xmlns:a="http://schemas.openxmlformats.org/drawingml/2006/main">
-            <a:pPr algn="just">
-              <a:lnSpc>
-                <a:spcPct val="160000"/>
-              </a:lnSpc>
-              <a:buNone/>
-            </a:pPr>
-            <a:r>
-              <a:rPr sz="1425"/>
-              <a:t>mechanism MVP 尚无 shared head / QAOA replay / formal blind result；598→581 仅开发观察。</a:t>
+              <a:t>边界｜workspace peak≤2（MCT 分解未计）；claim/formal/performance/generalization/hardware/advantage=false。</a:t>
             </a:r>
             <a:endParaRPr sz="2400" b="1">
               <a:solidFill>
@@ -10058,7 +10045,7 @@
             </a:pPr>
             <a:r>
               <a:rPr sz="6000" b="1"/>
-              <a:t>让每一次搜索预算都接受</a:t>
+              <a:t>四臂机制消融已经运行</a:t>
             </a:r>
             <a:endParaRPr sz="6000" b="1"/>
           </a:p>
@@ -10068,7 +10055,7 @@
             </a:pPr>
             <a:r>
               <a:rPr sz="6000" b="1"/>
-              <a:t>语义与端点证据检验</a:t>
+              <a:t>显著反向，进入 D1 诊断</a:t>
             </a:r>
             <a:endParaRPr sz="6000" b="1"/>
           </a:p>
@@ -10139,7 +10126,7 @@
           <p:nvPr/>
         </p:nvPicPr>
         <p:blipFill>
-          <a:blip xmlns:r="http://schemas.openxmlformats.org/officeDocument/2006/relationships" xmlns:a="http://schemas.openxmlformats.org/drawingml/2006/main" r:embed="Rf9b87d60ea594095"/>
+          <a:blip xmlns:r="http://schemas.openxmlformats.org/officeDocument/2006/relationships" xmlns:a="http://schemas.openxmlformats.org/drawingml/2006/main" r:embed="R0dd92d230ded4553"/>
           <a:stretch xmlns:a="http://schemas.openxmlformats.org/drawingml/2006/main">
             <a:fillRect l="0" t="0" r="0" b="0"/>
           </a:stretch>
@@ -10316,7 +10303,7 @@
           <p:nvPr/>
         </p:nvPicPr>
         <p:blipFill>
-          <a:blip xmlns:r="http://schemas.openxmlformats.org/officeDocument/2006/relationships" xmlns:a="http://schemas.openxmlformats.org/drawingml/2006/main" r:embed="R3caef6bc809849a7"/>
+          <a:blip xmlns:r="http://schemas.openxmlformats.org/officeDocument/2006/relationships" xmlns:a="http://schemas.openxmlformats.org/drawingml/2006/main" r:embed="R6b8d8408451c4743"/>
           <a:stretch xmlns:a="http://schemas.openxmlformats.org/drawingml/2006/main">
             <a:fillRect l="0" t="0" r="0" b="0"/>
           </a:stretch>
@@ -10940,7 +10927,7 @@
           <p:nvPr/>
         </p:nvPicPr>
         <p:blipFill>
-          <a:blip xmlns:r="http://schemas.openxmlformats.org/officeDocument/2006/relationships" xmlns:a="http://schemas.openxmlformats.org/drawingml/2006/main" r:embed="Rfe71c4e4747a439a"/>
+          <a:blip xmlns:r="http://schemas.openxmlformats.org/officeDocument/2006/relationships" xmlns:a="http://schemas.openxmlformats.org/drawingml/2006/main" r:embed="R1651c1a15e614f1f"/>
           <a:stretch xmlns:a="http://schemas.openxmlformats.org/drawingml/2006/main"/>
         </p:blipFill>
         <p:spPr>
@@ -10962,7 +10949,7 @@
           <p:nvPr/>
         </p:nvPicPr>
         <p:blipFill>
-          <a:blip xmlns:r="http://schemas.openxmlformats.org/officeDocument/2006/relationships" xmlns:a="http://schemas.openxmlformats.org/drawingml/2006/main" r:embed="R859b9ca1cf634499"/>
+          <a:blip xmlns:r="http://schemas.openxmlformats.org/officeDocument/2006/relationships" xmlns:a="http://schemas.openxmlformats.org/drawingml/2006/main" r:embed="R9c1120f42b4b4323"/>
           <a:stretch xmlns:a="http://schemas.openxmlformats.org/drawingml/2006/main"/>
         </p:blipFill>
         <p:spPr>
@@ -11081,7 +11068,7 @@
           <p:nvPr/>
         </p:nvPicPr>
         <p:blipFill>
-          <a:blip xmlns:r="http://schemas.openxmlformats.org/officeDocument/2006/relationships" xmlns:a="http://schemas.openxmlformats.org/drawingml/2006/main" r:embed="Rd3d47de895404fe9"/>
+          <a:blip xmlns:r="http://schemas.openxmlformats.org/officeDocument/2006/relationships" xmlns:a="http://schemas.openxmlformats.org/drawingml/2006/main" r:embed="Ra0fb187094874e32"/>
           <a:stretch xmlns:a="http://schemas.openxmlformats.org/drawingml/2006/main">
             <a:fillRect l="0" t="0" r="0" b="0"/>
           </a:stretch>
@@ -13355,7 +13342,7 @@
           <p:nvPr/>
         </p:nvPicPr>
         <p:blipFill>
-          <a:blip xmlns:r="http://schemas.openxmlformats.org/officeDocument/2006/relationships" xmlns:a="http://schemas.openxmlformats.org/drawingml/2006/main" r:embed="Rbb4fc88ebdc14efb"/>
+          <a:blip xmlns:r="http://schemas.openxmlformats.org/officeDocument/2006/relationships" xmlns:a="http://schemas.openxmlformats.org/drawingml/2006/main" r:embed="R8d1ae0c944ce41eb"/>
           <a:stretch xmlns:a="http://schemas.openxmlformats.org/drawingml/2006/main">
             <a:fillRect l="0" t="0" r="0" b="0"/>
           </a:stretch>
@@ -15457,7 +15444,7 @@
           <p:nvPr/>
         </p:nvPicPr>
         <p:blipFill>
-          <a:blip xmlns:r="http://schemas.openxmlformats.org/officeDocument/2006/relationships" xmlns:a="http://schemas.openxmlformats.org/drawingml/2006/main" r:embed="Rcb760e75cc6e4062"/>
+          <a:blip xmlns:r="http://schemas.openxmlformats.org/officeDocument/2006/relationships" xmlns:a="http://schemas.openxmlformats.org/drawingml/2006/main" r:embed="R366830f154144a77"/>
           <a:stretch xmlns:a="http://schemas.openxmlformats.org/drawingml/2006/main">
             <a:fillRect l="0" t="0" r="0" b="0"/>
           </a:stretch>
@@ -16518,7 +16505,7 @@
           <p:nvPr/>
         </p:nvPicPr>
         <p:blipFill>
-          <a:blip xmlns:r="http://schemas.openxmlformats.org/officeDocument/2006/relationships" xmlns:a="http://schemas.openxmlformats.org/drawingml/2006/main" r:embed="R938ef455c6434162"/>
+          <a:blip xmlns:r="http://schemas.openxmlformats.org/officeDocument/2006/relationships" xmlns:a="http://schemas.openxmlformats.org/drawingml/2006/main" r:embed="R3b51fcb2173d4830"/>
           <a:srcRect xmlns:a="http://schemas.openxmlformats.org/drawingml/2006/main" l="0" t="0" r="0" b="0"/>
           <a:stretch xmlns:a="http://schemas.openxmlformats.org/drawingml/2006/main">
             <a:fillRect l="0" t="0" r="0" b="0"/>
@@ -16965,7 +16952,7 @@
           <p:nvPr/>
         </p:nvPicPr>
         <p:blipFill>
-          <a:blip xmlns:r="http://schemas.openxmlformats.org/officeDocument/2006/relationships" xmlns:a="http://schemas.openxmlformats.org/drawingml/2006/main" r:embed="Re1e9b252da6941b4"/>
+          <a:blip xmlns:r="http://schemas.openxmlformats.org/officeDocument/2006/relationships" xmlns:a="http://schemas.openxmlformats.org/drawingml/2006/main" r:embed="Rc611d1d8d9974c47"/>
           <a:srcRect xmlns:a="http://schemas.openxmlformats.org/drawingml/2006/main" l="0" t="0" r="0" b="0"/>
           <a:stretch xmlns:a="http://schemas.openxmlformats.org/drawingml/2006/main">
             <a:fillRect l="0" t="0" r="0" b="0"/>
@@ -17284,7 +17271,7 @@
           <p:nvPr/>
         </p:nvPicPr>
         <p:blipFill>
-          <a:blip xmlns:r="http://schemas.openxmlformats.org/officeDocument/2006/relationships" xmlns:a="http://schemas.openxmlformats.org/drawingml/2006/main" r:embed="R9643ae93e81248d0"/>
+          <a:blip xmlns:r="http://schemas.openxmlformats.org/officeDocument/2006/relationships" xmlns:a="http://schemas.openxmlformats.org/drawingml/2006/main" r:embed="Rbcbae47d75874d46"/>
           <a:srcRect xmlns:a="http://schemas.openxmlformats.org/drawingml/2006/main" l="0" t="0" r="0" b="0"/>
           <a:stretch xmlns:a="http://schemas.openxmlformats.org/drawingml/2006/main">
             <a:fillRect l="0" t="0" r="0" b="0"/>
@@ -17406,7 +17393,7 @@
           <p:nvPr/>
         </p:nvPicPr>
         <p:blipFill>
-          <a:blip xmlns:r="http://schemas.openxmlformats.org/officeDocument/2006/relationships" xmlns:a="http://schemas.openxmlformats.org/drawingml/2006/main" r:embed="R509cf37ef8f74d6d"/>
+          <a:blip xmlns:r="http://schemas.openxmlformats.org/officeDocument/2006/relationships" xmlns:a="http://schemas.openxmlformats.org/drawingml/2006/main" r:embed="R31674843f5544c5c"/>
           <a:stretch xmlns:a="http://schemas.openxmlformats.org/drawingml/2006/main">
             <a:fillRect l="0" t="0" r="0" b="0"/>
           </a:stretch>
@@ -18328,7 +18315,7 @@
         </p:xfrm>
         <a:graphic xmlns:a="http://schemas.openxmlformats.org/drawingml/2006/main">
           <a:graphicData uri="http://schemas.openxmlformats.org/drawingml/2006/chart">
-            <c:chart xmlns:r="http://schemas.openxmlformats.org/officeDocument/2006/relationships" xmlns:c="http://schemas.openxmlformats.org/drawingml/2006/chart" r:id="Rb8e08b3793af4fd0"/>
+            <c:chart xmlns:r="http://schemas.openxmlformats.org/officeDocument/2006/relationships" xmlns:c="http://schemas.openxmlformats.org/drawingml/2006/chart" r:id="R0d420c6146a44b46"/>
           </a:graphicData>
         </a:graphic>
       </p:graphicFrame>
@@ -18344,7 +18331,7 @@
         </p:xfrm>
         <a:graphic xmlns:a="http://schemas.openxmlformats.org/drawingml/2006/main">
           <a:graphicData uri="http://schemas.openxmlformats.org/drawingml/2006/chart">
-            <c:chart xmlns:r="http://schemas.openxmlformats.org/officeDocument/2006/relationships" xmlns:c="http://schemas.openxmlformats.org/drawingml/2006/chart" r:id="R5235f479ae974be4"/>
+            <c:chart xmlns:r="http://schemas.openxmlformats.org/officeDocument/2006/relationships" xmlns:c="http://schemas.openxmlformats.org/drawingml/2006/chart" r:id="Rf50086a33b1346d0"/>
           </a:graphicData>
         </a:graphic>
       </p:graphicFrame>
@@ -18353,7 +18340,7 @@
           <p:cNvPr id="31" name="E1 diagnostic metrics">
             <a:extLst xmlns:a="http://schemas.openxmlformats.org/drawingml/2006/main">
               <a:ext uri="{FF2B5EF4-FFF2-40B4-BE49-F238E27FC236}">
-                <a16:creationId xmlns:a16="http://schemas.microsoft.com/office/drawing/2014/main" id="{AD9B4608-AEED-4441-9F54-226BE90F2329}"/>
+                <a16:creationId xmlns:a16="http://schemas.microsoft.com/office/drawing/2014/main" id="{EB01DCB3-B71B-409D-AB05-BA28D8A55612}"/>
               </a:ext>
             </a:extLst>
           </p:cNvPr>
@@ -18616,7 +18603,7 @@
           <p:nvPr/>
         </p:nvPicPr>
         <p:blipFill>
-          <a:blip xmlns:r="http://schemas.openxmlformats.org/officeDocument/2006/relationships" xmlns:a="http://schemas.openxmlformats.org/drawingml/2006/main" r:embed="Rf8dd8c57ef464045"/>
+          <a:blip xmlns:r="http://schemas.openxmlformats.org/officeDocument/2006/relationships" xmlns:a="http://schemas.openxmlformats.org/drawingml/2006/main" r:embed="R3c49cfd670394557"/>
           <a:stretch xmlns:a="http://schemas.openxmlformats.org/drawingml/2006/main">
             <a:fillRect l="0" t="0" r="0" b="0"/>
           </a:stretch>
@@ -19197,7 +19184,7 @@
           <p:nvPr/>
         </p:nvPicPr>
         <p:blipFill>
-          <a:blip xmlns:r="http://schemas.openxmlformats.org/officeDocument/2006/relationships" xmlns:a="http://schemas.openxmlformats.org/drawingml/2006/main" r:embed="R07d874d63ab04d27"/>
+          <a:blip xmlns:r="http://schemas.openxmlformats.org/officeDocument/2006/relationships" xmlns:a="http://schemas.openxmlformats.org/drawingml/2006/main" r:embed="R1bdad5bdc0754b02"/>
           <a:stretch xmlns:a="http://schemas.openxmlformats.org/drawingml/2006/main">
             <a:fillRect l="0" t="0" r="0" b="0"/>
           </a:stretch>
@@ -19468,7 +19455,7 @@
           <p:nvPr/>
         </p:nvPicPr>
         <p:blipFill>
-          <a:blip xmlns:r="http://schemas.openxmlformats.org/officeDocument/2006/relationships" xmlns:a="http://schemas.openxmlformats.org/drawingml/2006/main" r:embed="R07d874d63ab04d27"/>
+          <a:blip xmlns:r="http://schemas.openxmlformats.org/officeDocument/2006/relationships" xmlns:a="http://schemas.openxmlformats.org/drawingml/2006/main" r:embed="R1bdad5bdc0754b02"/>
           <a:stretch xmlns:a="http://schemas.openxmlformats.org/drawingml/2006/main">
             <a:fillRect l="0" t="0" r="0" b="0"/>
           </a:stretch>
@@ -19929,7 +19916,7 @@
           <p:nvPr/>
         </p:nvPicPr>
         <p:blipFill>
-          <a:blip xmlns:r="http://schemas.openxmlformats.org/officeDocument/2006/relationships" xmlns:a="http://schemas.openxmlformats.org/drawingml/2006/main" r:embed="R07d874d63ab04d27"/>
+          <a:blip xmlns:r="http://schemas.openxmlformats.org/officeDocument/2006/relationships" xmlns:a="http://schemas.openxmlformats.org/drawingml/2006/main" r:embed="R1bdad5bdc0754b02"/>
           <a:stretch xmlns:a="http://schemas.openxmlformats.org/drawingml/2006/main">
             <a:fillRect l="0" t="0" r="0" b="0"/>
           </a:stretch>
@@ -20526,7 +20513,7 @@
           <p:nvPr/>
         </p:nvPicPr>
         <p:blipFill>
-          <a:blip xmlns:r="http://schemas.openxmlformats.org/officeDocument/2006/relationships" xmlns:a="http://schemas.openxmlformats.org/drawingml/2006/main" r:embed="R1abca4bb588f47ed"/>
+          <a:blip xmlns:r="http://schemas.openxmlformats.org/officeDocument/2006/relationships" xmlns:a="http://schemas.openxmlformats.org/drawingml/2006/main" r:embed="R83a0ecfa937c4d14"/>
           <a:srcRect xmlns:a="http://schemas.openxmlformats.org/drawingml/2006/main" l="0" t="0" r="0" b="0"/>
           <a:stretch xmlns:a="http://schemas.openxmlformats.org/drawingml/2006/main">
             <a:fillRect l="0" t="0" r="0" b="0"/>
@@ -20628,7 +20615,7 @@
           <p:nvPr/>
         </p:nvPicPr>
         <p:blipFill>
-          <a:blip xmlns:r="http://schemas.openxmlformats.org/officeDocument/2006/relationships" xmlns:a="http://schemas.openxmlformats.org/drawingml/2006/main" r:embed="R07d874d63ab04d27"/>
+          <a:blip xmlns:r="http://schemas.openxmlformats.org/officeDocument/2006/relationships" xmlns:a="http://schemas.openxmlformats.org/drawingml/2006/main" r:embed="R1bdad5bdc0754b02"/>
           <a:stretch xmlns:a="http://schemas.openxmlformats.org/drawingml/2006/main">
             <a:fillRect l="0" t="0" r="0" b="0"/>
           </a:stretch>
@@ -21062,7 +21049,7 @@
           <p:nvPr/>
         </p:nvPicPr>
         <p:blipFill>
-          <a:blip xmlns:r="http://schemas.openxmlformats.org/officeDocument/2006/relationships" xmlns:a="http://schemas.openxmlformats.org/drawingml/2006/main" r:embed="R07d874d63ab04d27"/>
+          <a:blip xmlns:r="http://schemas.openxmlformats.org/officeDocument/2006/relationships" xmlns:a="http://schemas.openxmlformats.org/drawingml/2006/main" r:embed="R1bdad5bdc0754b02"/>
           <a:stretch xmlns:a="http://schemas.openxmlformats.org/drawingml/2006/main">
             <a:fillRect l="0" t="0" r="0" b="0"/>
           </a:stretch>
@@ -21742,7 +21729,7 @@
           <p:nvPr/>
         </p:nvPicPr>
         <p:blipFill>
-          <a:blip xmlns:r="http://schemas.openxmlformats.org/officeDocument/2006/relationships" xmlns:a="http://schemas.openxmlformats.org/drawingml/2006/main" r:embed="Ra91fcda1aea44c3e"/>
+          <a:blip xmlns:r="http://schemas.openxmlformats.org/officeDocument/2006/relationships" xmlns:a="http://schemas.openxmlformats.org/drawingml/2006/main" r:embed="R95e2459c3c994c28"/>
           <a:stretch xmlns:a="http://schemas.openxmlformats.org/drawingml/2006/main">
             <a:fillRect l="0" t="0" r="0" b="0"/>
           </a:stretch>
@@ -22307,7 +22294,7 @@
         </p:xfrm>
         <a:graphic xmlns:a="http://schemas.openxmlformats.org/drawingml/2006/main">
           <a:graphicData uri="http://schemas.openxmlformats.org/drawingml/2006/chart">
-            <c:chart xmlns:r="http://schemas.openxmlformats.org/officeDocument/2006/relationships" xmlns:c="http://schemas.openxmlformats.org/drawingml/2006/chart" r:id="R742934ee2cdc48cd"/>
+            <c:chart xmlns:r="http://schemas.openxmlformats.org/officeDocument/2006/relationships" xmlns:c="http://schemas.openxmlformats.org/drawingml/2006/chart" r:id="Rd6cd2312d9ca4e5a"/>
           </a:graphicData>
         </a:graphic>
       </p:graphicFrame>
@@ -22743,7 +22730,7 @@
           <p:nvPr/>
         </p:nvPicPr>
         <p:blipFill>
-          <a:blip xmlns:r="http://schemas.openxmlformats.org/officeDocument/2006/relationships" xmlns:a="http://schemas.openxmlformats.org/drawingml/2006/main" r:embed="R73a1602d59344d76"/>
+          <a:blip xmlns:r="http://schemas.openxmlformats.org/officeDocument/2006/relationships" xmlns:a="http://schemas.openxmlformats.org/drawingml/2006/main" r:embed="R4259a4c692fd42a0"/>
           <a:stretch xmlns:a="http://schemas.openxmlformats.org/drawingml/2006/main">
             <a:fillRect l="0" t="0" r="0" b="0"/>
           </a:stretch>

</xml_diff>

<commit_message>
Synchronize E6 D2 mechanism evidence
</commit_message>
<xml_diff>
--- a/docs/competition/slides/XA-202609_双向智能Boolean_Oracle答辩稿.pptx
+++ b/docs/competition/slides/XA-202609_双向智能Boolean_Oracle答辩稿.pptx
@@ -2,26 +2,26 @@
 <file path=ppt/presentation.xml><?xml version="1.0" encoding="utf-8"?>
 <p:presentation xmlns:p="http://schemas.openxmlformats.org/presentationml/2006/main">
   <p:sldMasterIdLst>
-    <p:sldMasterId xmlns:r="http://schemas.openxmlformats.org/officeDocument/2006/relationships" id="2147483648" r:id="R0041fd5312b14536"/>
+    <p:sldMasterId xmlns:r="http://schemas.openxmlformats.org/officeDocument/2006/relationships" id="2147483648" r:id="Ra1890ad31ba747b2"/>
   </p:sldMasterIdLst>
   <p:notesMasterIdLst>
-    <p:notesMasterId xmlns:r="http://schemas.openxmlformats.org/officeDocument/2006/relationships" r:id="R10353a50e3d64b69"/>
+    <p:notesMasterId xmlns:r="http://schemas.openxmlformats.org/officeDocument/2006/relationships" r:id="R6f4f2db25ce84893"/>
   </p:notesMasterIdLst>
   <p:sldIdLst>
-    <p:sldId xmlns:r="http://schemas.openxmlformats.org/officeDocument/2006/relationships" id="256" r:id="R9590c31d368741ec"/>
-    <p:sldId xmlns:r="http://schemas.openxmlformats.org/officeDocument/2006/relationships" id="257" r:id="R4fcfcd3336f241f6"/>
-    <p:sldId xmlns:r="http://schemas.openxmlformats.org/officeDocument/2006/relationships" id="258" r:id="Rb3b18648cfe046ed"/>
-    <p:sldId xmlns:r="http://schemas.openxmlformats.org/officeDocument/2006/relationships" id="259" r:id="Rb99898c2dc9e4ea4"/>
-    <p:sldId xmlns:r="http://schemas.openxmlformats.org/officeDocument/2006/relationships" id="260" r:id="R446399b796084182"/>
-    <p:sldId xmlns:r="http://schemas.openxmlformats.org/officeDocument/2006/relationships" id="261" r:id="R7b56d3327ddb43b6"/>
-    <p:sldId xmlns:r="http://schemas.openxmlformats.org/officeDocument/2006/relationships" id="262" r:id="Rdd7d9e5a10fe4b49"/>
-    <p:sldId xmlns:r="http://schemas.openxmlformats.org/officeDocument/2006/relationships" id="263" r:id="Rc17c11094a02423a"/>
-    <p:sldId xmlns:r="http://schemas.openxmlformats.org/officeDocument/2006/relationships" id="264" r:id="Re68c4f5fb0334491"/>
-    <p:sldId xmlns:r="http://schemas.openxmlformats.org/officeDocument/2006/relationships" id="265" r:id="R2e70a6405ebf45e9"/>
-    <p:sldId xmlns:r="http://schemas.openxmlformats.org/officeDocument/2006/relationships" id="266" r:id="R250da6dc15ee4044"/>
-    <p:sldId xmlns:r="http://schemas.openxmlformats.org/officeDocument/2006/relationships" id="267" r:id="R9b29081a494f4470"/>
-    <p:sldId xmlns:r="http://schemas.openxmlformats.org/officeDocument/2006/relationships" id="268" r:id="R2316df0d76b94313"/>
-    <p:sldId xmlns:r="http://schemas.openxmlformats.org/officeDocument/2006/relationships" id="269" r:id="R64dbc03e7a0f4e1f"/>
+    <p:sldId xmlns:r="http://schemas.openxmlformats.org/officeDocument/2006/relationships" id="256" r:id="R57528885fc264501"/>
+    <p:sldId xmlns:r="http://schemas.openxmlformats.org/officeDocument/2006/relationships" id="257" r:id="Re4d4e6622552489e"/>
+    <p:sldId xmlns:r="http://schemas.openxmlformats.org/officeDocument/2006/relationships" id="258" r:id="R800d084bfe454688"/>
+    <p:sldId xmlns:r="http://schemas.openxmlformats.org/officeDocument/2006/relationships" id="259" r:id="R874080abf8b94970"/>
+    <p:sldId xmlns:r="http://schemas.openxmlformats.org/officeDocument/2006/relationships" id="260" r:id="R5b7728521d794f11"/>
+    <p:sldId xmlns:r="http://schemas.openxmlformats.org/officeDocument/2006/relationships" id="261" r:id="R4443e33c1fad4507"/>
+    <p:sldId xmlns:r="http://schemas.openxmlformats.org/officeDocument/2006/relationships" id="262" r:id="R20d0637fb45c41b4"/>
+    <p:sldId xmlns:r="http://schemas.openxmlformats.org/officeDocument/2006/relationships" id="263" r:id="Rb42231585c1f4abe"/>
+    <p:sldId xmlns:r="http://schemas.openxmlformats.org/officeDocument/2006/relationships" id="264" r:id="Rd014f38e5df244c1"/>
+    <p:sldId xmlns:r="http://schemas.openxmlformats.org/officeDocument/2006/relationships" id="265" r:id="R95b1e73153834893"/>
+    <p:sldId xmlns:r="http://schemas.openxmlformats.org/officeDocument/2006/relationships" id="266" r:id="Rfbc33e48642d486f"/>
+    <p:sldId xmlns:r="http://schemas.openxmlformats.org/officeDocument/2006/relationships" id="267" r:id="R1ac6024190514dc2"/>
+    <p:sldId xmlns:r="http://schemas.openxmlformats.org/officeDocument/2006/relationships" id="268" r:id="Rfdf7cd11e7d04cfb"/>
+    <p:sldId xmlns:r="http://schemas.openxmlformats.org/officeDocument/2006/relationships" id="269" r:id="R5d43e9683abb40f2"/>
   </p:sldIdLst>
   <p:sldSz cx="12192000" cy="6858000"/>
   <p:notesSz cx="6858000" cy="9144000"/>
@@ -848,13 +848,13 @@
           <a:lstStyle xmlns:a="http://schemas.openxmlformats.org/drawingml/2006/main"/>
           <a:p xmlns:a="http://schemas.openxmlformats.org/drawingml/2006/main">
             <a:r>
-              <a:t>分层验证把语义正确性、调度实现、原生门与 bundle 完整性分别交给独立检查。</a:t>
+              <a:t>分层验证把语义正确性、调度实现、原生门与实验产物完整性分别交给独立检查。</a:t>
             </a:r>
             <a:endParaRPr/>
           </a:p>
           <a:p xmlns:a="http://schemas.openxmlformats.org/drawingml/2006/main">
             <a:r>
-              <a:t>当前集成树完整回归为 588 passed in 363.66s；legacy smoke 为 smoke ok。</a:t>
+              <a:t>当前集成树完整回归为 631 passed in 411.04s；legacy smoke 为 smoke ok。</a:t>
             </a:r>
             <a:endParaRPr/>
           </a:p>
@@ -866,24 +866,30 @@
           </a:p>
           <a:p xmlns:a="http://schemas.openxmlformats.org/drawingml/2006/main">
             <a:r>
-              <a:t>E6 五文件 full bundle 绑定 clean source e850c0c；固定语料、初始化和 seed 下四臂依次训练，独立 verifier 确定性重训并以 11/11 通过。该检查只闭合开发机制与复现，不是性能成功率。</a:t>
+              <a:t>D2 是单研究者、确定性、五文件 development 实验：共 800 rows（96 audit + 384 matched + 320 endpoint）；704/704 program diagnostic rows 语义通过，fallback/degraded 均为 0。</a:t>
             </a:r>
             <a:endParaRPr/>
           </a:p>
           <a:p xmlns:a="http://schemas.openxmlformats.org/drawingml/2006/main">
             <a:r>
-              <a:t>当前 38 页唯一中文主稿已同步 Overleaf origin/main 739b6c921e5c574871b12172024e2302aed8bb9c；本地 PDF SHA-256 为 fadd6965e39a390589086e1784e6e68984ce2121339dbace802775858d3fcfe3。</a:t>
+              <a:t>resource-gain teacher 只给观测到的可行 QAOA 联合 bitstring 正的 whole-program resource-gain credit；置换 control 只重排同一份 credit，不重算增益。</a:t>
             </a:r>
             <a:endParaRPr/>
           </a:p>
           <a:p xmlns:a="http://schemas.openxmlformats.org/drawingml/2006/main">
             <a:r>
-              <a:t>E4-v2 与 E5 历史证据边界不变；所有执行证据仍为 synthetic profile，formal/performance/generalization/hardware/advantage 均为 false。</a:t>
+              <a:t>当前 39 页中文主稿已同步 Overleaf origin/main cb6962eab16974ce7a5734ae43094a15abf99138；本地 PDF SHA-256 为 f6826f61595e5a7de9b311a13e6027b061c99323fbbdc626196986a7c3cbda95。</a:t>
             </a:r>
             <a:endParaRPr/>
           </a:p>
           <a:p xmlns:a="http://schemas.openxmlformats.org/drawingml/2006/main">
             <a:r>
+              <a:t>D2 只支持标签语义与因果机制修复；所有执行证据仍为 synthetic profile，formal/performance/hardware/advantage 均为 false。</a:t>
+            </a:r>
+            <a:endParaRPr/>
+          </a:p>
+          <a:p xmlns:a="http://schemas.openxmlformats.org/drawingml/2006/main">
+            <a:r>
               <a:t>[Sources]</a:t>
             </a:r>
             <a:endParaRPr/>
@@ -902,25 +908,25 @@
           </a:p>
           <a:p xmlns:a="http://schemas.openxmlformats.org/drawingml/2006/main">
             <a:r>
-              <a:t>- experiments/results/xa202609/20260812-e6-q4ai-causal-v1-full-s20260912/results.json</a:t>
+              <a:t>- experiments/results/xa202609/20260813-e6-d2-resource-gain-teacher-v1-full-s20261011/results.json</a:t>
             </a:r>
             <a:endParaRPr/>
           </a:p>
           <a:p xmlns:a="http://schemas.openxmlformats.org/drawingml/2006/main">
             <a:r>
-              <a:t>- experiments/results/xa202609/20260812-e6-q4ai-causal-v1-full-s20260912/heldout_evaluation.json</a:t>
+              <a:t>- experiments/results/xa202609/20260813-e6-d2-resource-gain-teacher-v1-full-s20261011/diagnostics.json</a:t>
             </a:r>
             <a:endParaRPr/>
           </a:p>
           <a:p xmlns:a="http://schemas.openxmlformats.org/drawingml/2006/main">
             <a:r>
-              <a:t>- experiments/scripts/verify_e6_replay_training_bundle_v1.py</a:t>
+              <a:t>- experiments/results/xa202609/20260813-e6-d2-resource-gain-teacher-v1-full-s20261011/checksums.sha256</a:t>
             </a:r>
             <a:endParaRPr/>
           </a:p>
           <a:p xmlns:a="http://schemas.openxmlformats.org/drawingml/2006/main">
             <a:r>
-              <a:t>- docs/competition/evidence/E6_Q4AI_CAUSAL_NEGATIVE_EVIDENCE.md</a:t>
+              <a:t>- docs/competition/evidence/E6_D2_RESOURCE_GAIN_MECHANISM_EVIDENCE.md</a:t>
             </a:r>
             <a:endParaRPr/>
           </a:p>
@@ -932,13 +938,13 @@
           </a:p>
           <a:p xmlns:a="http://schemas.openxmlformats.org/drawingml/2006/main">
             <a:r>
-              <a:t>- docs/papers/resource_nmcts/overleaf/worktree (origin/main 739b6c921e5c574871b12172024e2302aed8bb9c)</a:t>
+              <a:t>- docs/papers/resource_nmcts/overleaf/worktree (origin/main cb6962eab16974ce7a5734ae43094a15abf99138)</a:t>
             </a:r>
             <a:endParaRPr/>
           </a:p>
           <a:p xmlns:a="http://schemas.openxmlformats.org/drawingml/2006/main">
             <a:r>
-              <a:t>- docs/papers/resource_nmcts/chinese/resource_nmcts_competition_current.pdf (SHA-256 fadd6965e39a390589086e1784e6e68984ce2121339dbace802775858d3fcfe3)</a:t>
+              <a:t>- docs/papers/resource_nmcts/chinese/resource_nmcts_competition_current.pdf (SHA-256 f6826f61595e5a7de9b311a13e6027b061c99323fbbdc626196986a7c3cbda95)</a:t>
             </a:r>
             <a:endParaRPr/>
           </a:p>
@@ -1009,55 +1015,79 @@
           <a:lstStyle xmlns:a="http://schemas.openxmlformats.org/drawingml/2006/main"/>
           <a:p xmlns:a="http://schemas.openxmlformats.org/drawingml/2006/main">
             <a:r>
-              <a:t>E6 已实际运行 shared head、replay、trainer 与 exact scheduler 的四臂 development 机制消融，不再是尚未接入。</a:t>
+              <a:t>D1 的主要问题是 teacher 标签与 whole-program resource objective 错位。D2 只做一项干预：观测到的可行 QAOA 联合 bitstring 按正的实际资源增益给被选动作分配 credit。</a:t>
             </a:r>
             <a:endParaRPr/>
           </a:p>
           <a:p xmlns:a="http://schemas.openxmlformats.org/drawingml/2006/main">
             <a:r>
-              <a:t>主比较 QAOA final-measurement replay 减 permuted-label control 的下优资源比差为 +0.0949778，95% CI [0.0696384,0.1237673]，双侧 sign-flip p=9.9999e-6，W/T/L=0/3/29；n4/n5 分层均为正，claim_supported=false。</a:t>
+              <a:t>在 32 个 fresh structured development case 上，gain-weighted QAOA 相对 exact permuted-label control 的 ΔY 为 -0.1688789442，W/T/L=32/0/0；OOD n=4/5 上为 -0.1535114735，W/T/L=31/1/0。</a:t>
             </a:r>
             <a:endParaRPr/>
           </a:p>
           <a:p xmlns:a="http://schemas.openxmlformats.org/drawingml/2006/main">
             <a:r>
-              <a:t>QAOA 与 random 的 32/32 endpoint 相同，且两臂各有 31/32 空选择。固定设计下，当前 teacher 标签与下游资源目标错位；不能把单个置换标签 control 的胜出外推为置换标签普遍更好。</a:t>
+              <a:t>这说明 resource-aligned QAOA action label 保留了有意义的因果信息，并修复 D1 的错位标签语义。</a:t>
             </a:r>
             <a:endParaRPr/>
           </a:p>
           <a:p xmlns:a="http://schemas.openxmlformats.org/drawingml/2006/main">
             <a:r>
-              <a:t>D1 只诊断 replay 标签、head top-K 与 exact scheduler 的作用，不使用当前 heldout 选择模型或追逐正结果。</a:t>
+              <a:t>但 gain-weighted QAOA 相对 strongest greedy 仍略差：structured ΔY=+0.005990，W/T/L=1/26/5；OOD ΔY=+0.018765，W/T/L=3/14/15。</a:t>
             </a:r>
             <a:endParaRPr/>
           </a:p>
           <a:p xmlns:a="http://schemas.openxmlformats.org/drawingml/2006/main">
             <a:r>
-              <a:t>这里的 workspace peak≤2 和资源比只指 abstract logical X/CNOT/MCT proxy；MCT 分解未计，不是硬件精确门数。formal/performance/generalization/hardware/advantage 均为 false。</a:t>
+              <a:t>因此本轮只支持 development mechanism repair，不支持性能改善、量子优势、formal、generalization 或硬件主张。</a:t>
             </a:r>
             <a:endParaRPr/>
           </a:p>
           <a:p xmlns:a="http://schemas.openxmlformats.org/drawingml/2006/main">
             <a:r>
+              <a:t>下一步冻结 D2，在全新 seeds 和 matched-compute 预算下做 gain-QAOA vs strongest-greedy paired evaluation；预注册门为 ΔY&lt;0、95% CI upper&lt;0、语义 100%、0 fallback。</a:t>
+            </a:r>
+            <a:endParaRPr/>
+          </a:p>
+          <a:p xmlns:a="http://schemas.openxmlformats.org/drawingml/2006/main">
+            <a:r>
+              <a:t>这里的 workspace peak≤2 和 Y 只指 abstract logical X/CNOT/MCT proxy；MCT 分解未计，不是硬件精确门数。</a:t>
+            </a:r>
+            <a:endParaRPr/>
+          </a:p>
+          <a:p xmlns:a="http://schemas.openxmlformats.org/drawingml/2006/main">
+            <a:r>
               <a:t>[Sources]</a:t>
             </a:r>
             <a:endParaRPr/>
           </a:p>
           <a:p xmlns:a="http://schemas.openxmlformats.org/drawingml/2006/main">
             <a:r>
-              <a:t>- docs/competition/evidence/E6_Q4AI_CAUSAL_NEGATIVE_EVIDENCE.md</a:t>
+              <a:t>- docs/competition/evidence/E6_D2_RESOURCE_GAIN_MECHANISM_EVIDENCE.md</a:t>
             </a:r>
             <a:endParaRPr/>
           </a:p>
           <a:p xmlns:a="http://schemas.openxmlformats.org/drawingml/2006/main">
             <a:r>
-              <a:t>- experiments/results/xa202609/20260812-e6-q4ai-causal-v1-full-s20260912/results.json</a:t>
+              <a:t>- experiments/results/xa202609/20260813-e6-d2-resource-gain-teacher-v1-full-s20261011/results.json</a:t>
             </a:r>
             <a:endParaRPr/>
           </a:p>
           <a:p xmlns:a="http://schemas.openxmlformats.org/drawingml/2006/main">
             <a:r>
-              <a:t>- experiments/results/xa202609/20260812-e6-q4ai-causal-v1-full-s20260912/heldout_evaluation.json</a:t>
+              <a:t>- experiments/results/xa202609/20260813-e6-d2-resource-gain-teacher-v1-full-s20261011/diagnostics.json</a:t>
+            </a:r>
+            <a:endParaRPr/>
+          </a:p>
+          <a:p xmlns:a="http://schemas.openxmlformats.org/drawingml/2006/main">
+            <a:r>
+              <a:t>- experiments/results/xa202609/20260813-e6-d2-resource-gain-teacher-v1-full-s20261011/raw.jsonl</a:t>
+            </a:r>
+            <a:endParaRPr/>
+          </a:p>
+          <a:p xmlns:a="http://schemas.openxmlformats.org/drawingml/2006/main">
+            <a:r>
+              <a:t>- experiments/configs/xa202609/e6_d2_resource_gain_teacher_v1.json</a:t>
             </a:r>
             <a:endParaRPr/>
           </a:p>
@@ -1152,19 +1182,19 @@
           <a:lstStyle xmlns:a="http://schemas.openxmlformats.org/drawingml/2006/main"/>
           <a:p xmlns:a="http://schemas.openxmlformats.org/drawingml/2006/main">
             <a:r>
-              <a:t>收束：AI4Q 与 Q4AI 已在同一开发链中贯通，四臂实验给出显著反向而不是期望中的改善。</a:t>
+              <a:t>收束：AI4Q 与 Q4AI 的开发链已从 D1 错位标签推进到 D2 resource-aligned replay；相对 exact permuted-label control，structured 32/32 逐例更低，OOD 31/32 更低且 1 tie。</a:t>
             </a:r>
             <a:endParaRPr/>
           </a:p>
           <a:p xmlns:a="http://schemas.openxmlformats.org/drawingml/2006/main">
             <a:r>
-              <a:t>固定条件下，当前 QAOA teacher 标签关联对资源目标有害；这不是量子优势、性能、泛化、formal 或硬件证据。</a:t>
+              <a:t>strongest greedy 仍略优，因此当前结论是机制修复，不是性能、量子优势、formal、generalization 或硬件证据。</a:t>
             </a:r>
             <a:endParaRPr/>
           </a:p>
           <a:p xmlns:a="http://schemas.openxmlformats.org/drawingml/2006/main">
             <a:r>
-              <a:t>下一步直接做 D1 机制诊断，拆解 replay 标签、head top-K 与 exact scheduler；不在当前 heldout 事后调参。</a:t>
+              <a:t>下一步不再改 teacher：冻结 D2，用全新 seeds 和匹配计算预算直接对 strongest greedy 做 paired evaluation。</a:t>
             </a:r>
             <a:endParaRPr/>
           </a:p>
@@ -1176,13 +1206,13 @@
           </a:p>
           <a:p xmlns:a="http://schemas.openxmlformats.org/drawingml/2006/main">
             <a:r>
-              <a:t>- docs/competition/evidence/E6_Q4AI_CAUSAL_NEGATIVE_EVIDENCE.md</a:t>
+              <a:t>- docs/competition/evidence/E6_D2_RESOURCE_GAIN_MECHANISM_EVIDENCE.md</a:t>
             </a:r>
             <a:endParaRPr/>
           </a:p>
           <a:p xmlns:a="http://schemas.openxmlformats.org/drawingml/2006/main">
             <a:r>
-              <a:t>- experiments/results/xa202609/20260812-e6-q4ai-causal-v1-full-s20260912/results.json</a:t>
+              <a:t>- experiments/results/xa202609/20260813-e6-d2-resource-gain-teacher-v1-full-s20261011/results.json</a:t>
             </a:r>
             <a:endParaRPr/>
           </a:p>
@@ -4924,17 +4954,17 @@
   </p:cSld>
   <p:clrMap bg1="lt1" tx1="dk1" bg2="lt2" tx2="dk2" accent1="accent1" accent2="accent2" accent3="accent3" accent4="accent4" accent5="accent5" accent6="accent6" hlink="hlink" folHlink="folHlink"/>
   <p:sldLayoutIdLst>
-    <p:sldLayoutId xmlns:r="http://schemas.openxmlformats.org/officeDocument/2006/relationships" id="2147483649" r:id="R89e0a361beb443a1"/>
-    <p:sldLayoutId xmlns:r="http://schemas.openxmlformats.org/officeDocument/2006/relationships" id="2147483650" r:id="R2dccb318e6734aca"/>
-    <p:sldLayoutId xmlns:r="http://schemas.openxmlformats.org/officeDocument/2006/relationships" id="2147483651" r:id="Rbd14a3e21f054617"/>
-    <p:sldLayoutId xmlns:r="http://schemas.openxmlformats.org/officeDocument/2006/relationships" id="2147483652" r:id="R64ad71240b564115"/>
-    <p:sldLayoutId xmlns:r="http://schemas.openxmlformats.org/officeDocument/2006/relationships" id="2147483653" r:id="R532d60fca29348b2"/>
-    <p:sldLayoutId xmlns:r="http://schemas.openxmlformats.org/officeDocument/2006/relationships" id="2147483654" r:id="R676a8f9165ee4b3d"/>
-    <p:sldLayoutId xmlns:r="http://schemas.openxmlformats.org/officeDocument/2006/relationships" id="2147483655" r:id="Re80a02e3f1ee44a5"/>
-    <p:sldLayoutId xmlns:r="http://schemas.openxmlformats.org/officeDocument/2006/relationships" id="2147483656" r:id="Rdb28332c94834514"/>
-    <p:sldLayoutId xmlns:r="http://schemas.openxmlformats.org/officeDocument/2006/relationships" id="2147483657" r:id="Rb86bbb0334384aa1"/>
-    <p:sldLayoutId xmlns:r="http://schemas.openxmlformats.org/officeDocument/2006/relationships" id="2147483658" r:id="Ra1bfda86c6284f23"/>
-    <p:sldLayoutId xmlns:r="http://schemas.openxmlformats.org/officeDocument/2006/relationships" id="2147483659" r:id="Rf10455007d894e34"/>
+    <p:sldLayoutId xmlns:r="http://schemas.openxmlformats.org/officeDocument/2006/relationships" id="2147483649" r:id="Re255b6560c894d79"/>
+    <p:sldLayoutId xmlns:r="http://schemas.openxmlformats.org/officeDocument/2006/relationships" id="2147483650" r:id="R736dae6692264834"/>
+    <p:sldLayoutId xmlns:r="http://schemas.openxmlformats.org/officeDocument/2006/relationships" id="2147483651" r:id="R5579f4c2d5ed40be"/>
+    <p:sldLayoutId xmlns:r="http://schemas.openxmlformats.org/officeDocument/2006/relationships" id="2147483652" r:id="R51017297f4db4762"/>
+    <p:sldLayoutId xmlns:r="http://schemas.openxmlformats.org/officeDocument/2006/relationships" id="2147483653" r:id="Rc27c1ee74f35448b"/>
+    <p:sldLayoutId xmlns:r="http://schemas.openxmlformats.org/officeDocument/2006/relationships" id="2147483654" r:id="R7380cbb045264116"/>
+    <p:sldLayoutId xmlns:r="http://schemas.openxmlformats.org/officeDocument/2006/relationships" id="2147483655" r:id="R877132d6e85f42c5"/>
+    <p:sldLayoutId xmlns:r="http://schemas.openxmlformats.org/officeDocument/2006/relationships" id="2147483656" r:id="Rbeda3b7de6b245ce"/>
+    <p:sldLayoutId xmlns:r="http://schemas.openxmlformats.org/officeDocument/2006/relationships" id="2147483657" r:id="R19cdfbeb019c42f0"/>
+    <p:sldLayoutId xmlns:r="http://schemas.openxmlformats.org/officeDocument/2006/relationships" id="2147483658" r:id="Rf67447d879ed4f9a"/>
+    <p:sldLayoutId xmlns:r="http://schemas.openxmlformats.org/officeDocument/2006/relationships" id="2147483659" r:id="R718702c320ca43f1"/>
   </p:sldLayoutIdLst>
   <p:txStyles>
     <p:titleStyle>
@@ -5683,6 +5713,7 @@
     <c:plotArea>
       <c:lineChart>
         <c:grouping val="standard"/>
+        <c:varyColors val="0"/>
         <c:ser>
           <c:idx val="0"/>
           <c:order val="0"/>
@@ -6137,6 +6168,7 @@
     <c:plotArea>
       <c:lineChart>
         <c:grouping val="standard"/>
+        <c:varyColors val="0"/>
         <c:ser>
           <c:idx val="0"/>
           <c:order val="0"/>
@@ -6394,6 +6426,7 @@
     <c:plotArea>
       <c:lineChart>
         <c:grouping val="standard"/>
+        <c:varyColors val="0"/>
         <c:ser>
           <c:idx val="0"/>
           <c:order val="0"/>
@@ -6764,7 +6797,7 @@
           <p:nvPr/>
         </p:nvPicPr>
         <p:blipFill>
-          <a:blip xmlns:r="http://schemas.openxmlformats.org/officeDocument/2006/relationships" xmlns:a="http://schemas.openxmlformats.org/drawingml/2006/main" r:embed="Ra561820502514a77"/>
+          <a:blip xmlns:r="http://schemas.openxmlformats.org/officeDocument/2006/relationships" xmlns:a="http://schemas.openxmlformats.org/drawingml/2006/main" r:embed="R5c69a9dc5fe94d46"/>
           <a:stretch xmlns:a="http://schemas.openxmlformats.org/drawingml/2006/main">
             <a:fillRect l="0" t="0" r="0" b="0"/>
           </a:stretch>
@@ -6927,7 +6960,7 @@
           <p:nvPr/>
         </p:nvPicPr>
         <p:blipFill>
-          <a:blip xmlns:r="http://schemas.openxmlformats.org/officeDocument/2006/relationships" xmlns:a="http://schemas.openxmlformats.org/drawingml/2006/main" r:embed="Rabc7b2b03977459c"/>
+          <a:blip xmlns:r="http://schemas.openxmlformats.org/officeDocument/2006/relationships" xmlns:a="http://schemas.openxmlformats.org/drawingml/2006/main" r:embed="R4fc875e50fc743fa"/>
           <a:srcRect xmlns:a="http://schemas.openxmlformats.org/drawingml/2006/main" l="0" t="0" r="0" b="0"/>
           <a:stretch xmlns:a="http://schemas.openxmlformats.org/drawingml/2006/main">
             <a:fillRect l="0" t="0" r="0" b="0"/>
@@ -7042,14 +7075,14 @@
       </p:sp>
       <p:pic>
         <p:nvPicPr>
-          <p:cNvPr id="32" name="图片 4"/>
+          <p:cNvPr id="27" name="图片 4"/>
           <p:cNvPicPr>
             <a:picLocks xmlns:a="http://schemas.openxmlformats.org/drawingml/2006/main" noChangeAspect="1"/>
           </p:cNvPicPr>
           <p:nvPr/>
         </p:nvPicPr>
         <p:blipFill>
-          <a:blip xmlns:r="http://schemas.openxmlformats.org/officeDocument/2006/relationships" xmlns:a="http://schemas.openxmlformats.org/drawingml/2006/main" r:embed="Radb635589df0414a"/>
+          <a:blip xmlns:r="http://schemas.openxmlformats.org/officeDocument/2006/relationships" xmlns:a="http://schemas.openxmlformats.org/drawingml/2006/main" r:embed="R3f1415a4c9334e6b"/>
           <a:stretch xmlns:a="http://schemas.openxmlformats.org/drawingml/2006/main">
             <a:fillRect l="0" t="0" r="0" b="0"/>
           </a:stretch>
@@ -7716,7 +7749,7 @@
       </p:sp>
       <p:graphicFrame>
         <p:nvGraphicFramePr>
-          <p:cNvPr id="39" name="Chart"/>
+          <p:cNvPr id="34" name="Chart"/>
           <p:cNvGraphicFramePr/>
           <p:nvPr/>
         </p:nvGraphicFramePr>
@@ -7726,7 +7759,7 @@
         </p:xfrm>
         <a:graphic xmlns:a="http://schemas.openxmlformats.org/drawingml/2006/main">
           <a:graphicData uri="http://schemas.openxmlformats.org/drawingml/2006/chart">
-            <c:chart xmlns:r="http://schemas.openxmlformats.org/officeDocument/2006/relationships" xmlns:c="http://schemas.openxmlformats.org/drawingml/2006/chart" r:id="R4b51629cc80042c8"/>
+            <c:chart xmlns:r="http://schemas.openxmlformats.org/officeDocument/2006/relationships" xmlns:c="http://schemas.openxmlformats.org/drawingml/2006/chart" r:id="Rc302567601254c4f"/>
           </a:graphicData>
         </a:graphic>
       </p:graphicFrame>
@@ -7829,14 +7862,14 @@
       </p:sp>
       <p:pic>
         <p:nvPicPr>
-          <p:cNvPr id="43" name="图片 4"/>
+          <p:cNvPr id="45" name="图片 4"/>
           <p:cNvPicPr>
             <a:picLocks xmlns:a="http://schemas.openxmlformats.org/drawingml/2006/main" noChangeAspect="1"/>
           </p:cNvPicPr>
           <p:nvPr/>
         </p:nvPicPr>
         <p:blipFill>
-          <a:blip xmlns:r="http://schemas.openxmlformats.org/officeDocument/2006/relationships" xmlns:a="http://schemas.openxmlformats.org/drawingml/2006/main" r:embed="Rc0c16e93d1de435f"/>
+          <a:blip xmlns:r="http://schemas.openxmlformats.org/officeDocument/2006/relationships" xmlns:a="http://schemas.openxmlformats.org/drawingml/2006/main" r:embed="R11671658447a4813"/>
           <a:stretch xmlns:a="http://schemas.openxmlformats.org/drawingml/2006/main">
             <a:fillRect l="0" t="0" r="0" b="0"/>
           </a:stretch>
@@ -8453,7 +8486,7 @@
       </p:sp>
       <p:graphicFrame>
         <p:nvGraphicFramePr>
-          <p:cNvPr id="52" name="Chart"/>
+          <p:cNvPr id="54" name="Chart"/>
           <p:cNvGraphicFramePr/>
           <p:nvPr/>
         </p:nvGraphicFramePr>
@@ -8463,7 +8496,7 @@
         </p:xfrm>
         <a:graphic xmlns:a="http://schemas.openxmlformats.org/drawingml/2006/main">
           <a:graphicData uri="http://schemas.openxmlformats.org/drawingml/2006/chart">
-            <c:chart xmlns:r="http://schemas.openxmlformats.org/officeDocument/2006/relationships" xmlns:c="http://schemas.openxmlformats.org/drawingml/2006/chart" r:id="R4b37481918c34ba6"/>
+            <c:chart xmlns:r="http://schemas.openxmlformats.org/officeDocument/2006/relationships" xmlns:c="http://schemas.openxmlformats.org/drawingml/2006/chart" r:id="R97c50827488e4c93"/>
           </a:graphicData>
         </a:graphic>
       </p:graphicFrame>
@@ -8504,6 +8537,7 @@
           <a:lstStyle xmlns:a="http://schemas.openxmlformats.org/drawingml/2006/main"/>
           <a:p xmlns:a="http://schemas.openxmlformats.org/drawingml/2006/main">
             <a:pPr algn="ctr">
+              <a:buNone/>
               <a:defRPr sz="1500" b="1">
                 <a:solidFill>
                   <a:srgbClr val="2F5597"/>
@@ -8527,6 +8561,7 @@
           </a:p>
           <a:p xmlns:a="http://schemas.openxmlformats.org/drawingml/2006/main">
             <a:pPr algn="ctr">
+              <a:buNone/>
               <a:defRPr sz="1500" b="1">
                 <a:solidFill>
                   <a:srgbClr val="2F5597"/>
@@ -8552,7 +8587,7 @@
       </p:sp>
       <p:graphicFrame>
         <p:nvGraphicFramePr>
-          <p:cNvPr id="54" name=""/>
+          <p:cNvPr id="56" name=""/>
           <p:cNvGraphicFramePr/>
           <p:nvPr/>
         </p:nvGraphicFramePr>
@@ -9054,7 +9089,7 @@
           <p:nvPr/>
         </p:nvPicPr>
         <p:blipFill>
-          <a:blip xmlns:r="http://schemas.openxmlformats.org/officeDocument/2006/relationships" xmlns:a="http://schemas.openxmlformats.org/drawingml/2006/main" r:embed="R68510c1603bd4b89"/>
+          <a:blip xmlns:r="http://schemas.openxmlformats.org/officeDocument/2006/relationships" xmlns:a="http://schemas.openxmlformats.org/drawingml/2006/main" r:embed="Rf4fc59597fc24384"/>
           <a:stretch xmlns:a="http://schemas.openxmlformats.org/drawingml/2006/main">
             <a:fillRect l="0" t="0" r="0" b="0"/>
           </a:stretch>
@@ -9241,7 +9276,7 @@
           <p:nvPr/>
         </p:nvPicPr>
         <p:blipFill>
-          <a:blip xmlns:r="http://schemas.openxmlformats.org/officeDocument/2006/relationships" xmlns:a="http://schemas.openxmlformats.org/drawingml/2006/main" r:embed="R19898a5d96954e38"/>
+          <a:blip xmlns:r="http://schemas.openxmlformats.org/officeDocument/2006/relationships" xmlns:a="http://schemas.openxmlformats.org/drawingml/2006/main" r:embed="R5366bef9e13a4963"/>
           <a:srcRect xmlns:a="http://schemas.openxmlformats.org/drawingml/2006/main" l="0" t="0" r="0" b="0"/>
           <a:stretch xmlns:a="http://schemas.openxmlformats.org/drawingml/2006/main">
             <a:fillRect l="0" t="0" r="0" b="0"/>
@@ -9307,7 +9342,7 @@
                 <a:ea typeface="微软雅黑"/>
                 <a:cs typeface="微软雅黑"/>
               </a:rPr>
-              <a:t>● 588 tests + smoke ok｜E6 四臂 development 已闭合；语义全过、fallback=0、verifier 11/11</a:t>
+              <a:t>● 631 tests + smoke ok｜D2 五文件 development：704/704 语义通过、fallback=0</a:t>
             </a:r>
             <a:endParaRPr sz="2400" b="1">
               <a:solidFill>
@@ -9336,7 +9371,7 @@
                 <a:ea typeface="微软雅黑"/>
                 <a:cs typeface="微软雅黑"/>
               </a:rPr>
-              <a:t>● 38 页中文主稿已同步 Overleaf｜claim/formal/performance/generalization/hardware=false</a:t>
+              <a:t>● 39 页中文主稿已同步 Overleaf｜mechanism repair；formal/performance/hardware=false</a:t>
             </a:r>
             <a:endParaRPr sz="2400" b="1">
               <a:solidFill>
@@ -9410,7 +9445,7 @@
                 <a:ea typeface="微软雅黑"/>
                 <a:cs typeface="微软雅黑"/>
               </a:rPr>
-              <a:t>E6 full bundle｜verifier 11/11</a:t>
+              <a:t>D2 five-file bundle｜704/704 semantics</a:t>
             </a:r>
             <a:endParaRPr b="1">
               <a:solidFill>
@@ -9440,7 +9475,7 @@
                 <a:ea typeface="微软雅黑"/>
                 <a:cs typeface="微软雅黑"/>
               </a:rPr>
-              <a:t>formal/performance/hardware=false</a:t>
+              <a:t>mechanism repair｜performance=false</a:t>
             </a:r>
             <a:endParaRPr b="1">
               <a:solidFill>
@@ -9462,7 +9497,7 @@
           <p:nvPr/>
         </p:nvPicPr>
         <p:blipFill>
-          <a:blip xmlns:r="http://schemas.openxmlformats.org/officeDocument/2006/relationships" xmlns:a="http://schemas.openxmlformats.org/drawingml/2006/main" r:embed="Rf8a6ed6c4c554d78"/>
+          <a:blip xmlns:r="http://schemas.openxmlformats.org/officeDocument/2006/relationships" xmlns:a="http://schemas.openxmlformats.org/drawingml/2006/main" r:embed="R8de7b7690947426f"/>
           <a:srcRect xmlns:a="http://schemas.openxmlformats.org/drawingml/2006/main" l="0" t="0" r="0" b="0"/>
           <a:stretch xmlns:a="http://schemas.openxmlformats.org/drawingml/2006/main">
             <a:fillRect l="0" t="0" r="0" b="0"/>
@@ -9584,7 +9619,7 @@
           <p:nvPr/>
         </p:nvPicPr>
         <p:blipFill>
-          <a:blip xmlns:r="http://schemas.openxmlformats.org/officeDocument/2006/relationships" xmlns:a="http://schemas.openxmlformats.org/drawingml/2006/main" r:embed="R226d2436a8ca4566"/>
+          <a:blip xmlns:r="http://schemas.openxmlformats.org/officeDocument/2006/relationships" xmlns:a="http://schemas.openxmlformats.org/drawingml/2006/main" r:embed="Rcd4f484f3b5942c2"/>
           <a:stretch xmlns:a="http://schemas.openxmlformats.org/drawingml/2006/main">
             <a:fillRect l="0" t="0" r="0" b="0"/>
           </a:stretch>
@@ -9657,7 +9692,7 @@
                 <a:ea typeface="黑体"/>
                 <a:cs typeface="黑体"/>
               </a:rPr>
-              <a:t>E6：反向结果指向 D1 诊断</a:t>
+              <a:t>E6-D2：资源增益标签修复机制</a:t>
             </a:r>
             <a:endParaRPr sz="4800" b="1">
               <a:ln w="10160">
@@ -9811,7 +9846,7 @@
                 <a:ea typeface="微软雅黑"/>
                 <a:cs typeface="微软雅黑"/>
               </a:rPr>
-              <a:t>AI4Q｜shared head → replay → trainer 已贯通；64 train + 32 whole-vector development，语义全过、0 fallback。</a:t>
+              <a:t>AI4Q｜resource-gain teacher → replay → shared head；704/704 语义通过，0 fallback。</a:t>
             </a:r>
             <a:endParaRPr sz="2400" b="1">
               <a:solidFill>
@@ -9831,7 +9866,7 @@
             </a:pPr>
             <a:r>
               <a:rPr sz="1425"/>
-              <a:t>Q4AI｜固定条件下，当前 teacher 标签关联显著有害。</a:t>
+              <a:t>Q4AI｜structured：gain−permuted ΔY=−0.168879，W/T/L=32/0/0。</a:t>
             </a:r>
             <a:endParaRPr sz="2400" b="1">
               <a:solidFill>
@@ -9857,7 +9892,7 @@
                   </a:schemeClr>
                 </a:solidFill>
               </a:rPr>
-              <a:t>资源比差（QAOA−置换标签）=+0.094978（越低越好）</a:t>
+              <a:t>OOD｜ΔY=−0.153511，W/T/L=31/1/0；D1 标签语义错位已被修复。</a:t>
             </a:r>
             <a:endParaRPr sz="2400" b="1">
               <a:latin typeface="微软雅黑"/>
@@ -9874,7 +9909,7 @@
             </a:pPr>
             <a:r>
               <a:rPr sz="1425"/>
-              <a:t>95% CI [0.069638,0.123767]｜p=9.9999e-6｜W/T/L=0/3/29</a:t>
+              <a:t>边界｜对 strongest greedy 仍略差：structured +0.005990；OOD +0.018765。</a:t>
             </a:r>
             <a:endParaRPr sz="2400" b="1">
               <a:solidFill>
@@ -9899,7 +9934,7 @@
                   </a:schemeClr>
                 </a:solidFill>
               </a:rPr>
-              <a:t>QAOA/random：32/32 endpoint 相同，均有 31/32 空选择。</a:t>
+              <a:t>判读｜development mechanism repair；不构成 formal/performance/quantum-advantage evidence。</a:t>
             </a:r>
             <a:endParaRPr sz="2400" b="1">
               <a:solidFill>
@@ -9918,7 +9953,7 @@
             </a:pPr>
             <a:r>
               <a:rPr sz="1425"/>
-              <a:t>D1｜拆解 replay 标签 → head top-K → exact scheduler；不在当前 heldout 事后调参。</a:t>
+              <a:t>NEXT｜冻结 D2；全新 seeds、matched compute 对 strongest greedy 做 paired evaluation。</a:t>
             </a:r>
             <a:endParaRPr sz="2400" b="1">
               <a:solidFill>
@@ -9940,7 +9975,7 @@
             </a:pPr>
             <a:r>
               <a:rPr sz="1425"/>
-              <a:t>边界｜workspace peak≤2（MCT 分解未计）；claim/formal/performance/generalization/hardware/advantage=false。</a:t>
+              <a:t>资源｜abstract logical X/CNOT/MCT proxy；workspace peak≤2（MCT 分解未计）。</a:t>
             </a:r>
             <a:endParaRPr sz="2400" b="1">
               <a:solidFill>
@@ -10045,7 +10080,7 @@
             </a:pPr>
             <a:r>
               <a:rPr sz="6000" b="1"/>
-              <a:t>四臂机制消融已经运行</a:t>
+              <a:t>资源一致 replay 修复标签语义</a:t>
             </a:r>
             <a:endParaRPr sz="6000" b="1"/>
           </a:p>
@@ -10055,7 +10090,7 @@
             </a:pPr>
             <a:r>
               <a:rPr sz="6000" b="1"/>
-              <a:t>显著反向，进入 D1 诊断</a:t>
+              <a:t>下一门：新种子匹配预算对照</a:t>
             </a:r>
             <a:endParaRPr sz="6000" b="1"/>
           </a:p>
@@ -10126,7 +10161,7 @@
           <p:nvPr/>
         </p:nvPicPr>
         <p:blipFill>
-          <a:blip xmlns:r="http://schemas.openxmlformats.org/officeDocument/2006/relationships" xmlns:a="http://schemas.openxmlformats.org/drawingml/2006/main" r:embed="R0dd92d230ded4553"/>
+          <a:blip xmlns:r="http://schemas.openxmlformats.org/officeDocument/2006/relationships" xmlns:a="http://schemas.openxmlformats.org/drawingml/2006/main" r:embed="Rdd24c897c39c411c"/>
           <a:stretch xmlns:a="http://schemas.openxmlformats.org/drawingml/2006/main">
             <a:fillRect l="0" t="0" r="0" b="0"/>
           </a:stretch>
@@ -10303,7 +10338,7 @@
           <p:nvPr/>
         </p:nvPicPr>
         <p:blipFill>
-          <a:blip xmlns:r="http://schemas.openxmlformats.org/officeDocument/2006/relationships" xmlns:a="http://schemas.openxmlformats.org/drawingml/2006/main" r:embed="R6b8d8408451c4743"/>
+          <a:blip xmlns:r="http://schemas.openxmlformats.org/officeDocument/2006/relationships" xmlns:a="http://schemas.openxmlformats.org/drawingml/2006/main" r:embed="R2283ab1baa4942fb"/>
           <a:stretch xmlns:a="http://schemas.openxmlformats.org/drawingml/2006/main">
             <a:fillRect l="0" t="0" r="0" b="0"/>
           </a:stretch>
@@ -10927,7 +10962,7 @@
           <p:nvPr/>
         </p:nvPicPr>
         <p:blipFill>
-          <a:blip xmlns:r="http://schemas.openxmlformats.org/officeDocument/2006/relationships" xmlns:a="http://schemas.openxmlformats.org/drawingml/2006/main" r:embed="R1651c1a15e614f1f"/>
+          <a:blip xmlns:r="http://schemas.openxmlformats.org/officeDocument/2006/relationships" xmlns:a="http://schemas.openxmlformats.org/drawingml/2006/main" r:embed="R40b0165bc51948dd"/>
           <a:stretch xmlns:a="http://schemas.openxmlformats.org/drawingml/2006/main"/>
         </p:blipFill>
         <p:spPr>
@@ -10949,7 +10984,7 @@
           <p:nvPr/>
         </p:nvPicPr>
         <p:blipFill>
-          <a:blip xmlns:r="http://schemas.openxmlformats.org/officeDocument/2006/relationships" xmlns:a="http://schemas.openxmlformats.org/drawingml/2006/main" r:embed="R9c1120f42b4b4323"/>
+          <a:blip xmlns:r="http://schemas.openxmlformats.org/officeDocument/2006/relationships" xmlns:a="http://schemas.openxmlformats.org/drawingml/2006/main" r:embed="R71002b99004245d5"/>
           <a:stretch xmlns:a="http://schemas.openxmlformats.org/drawingml/2006/main"/>
         </p:blipFill>
         <p:spPr>
@@ -11068,7 +11103,7 @@
           <p:nvPr/>
         </p:nvPicPr>
         <p:blipFill>
-          <a:blip xmlns:r="http://schemas.openxmlformats.org/officeDocument/2006/relationships" xmlns:a="http://schemas.openxmlformats.org/drawingml/2006/main" r:embed="Ra0fb187094874e32"/>
+          <a:blip xmlns:r="http://schemas.openxmlformats.org/officeDocument/2006/relationships" xmlns:a="http://schemas.openxmlformats.org/drawingml/2006/main" r:embed="R305f912d0a9f4d6f"/>
           <a:stretch xmlns:a="http://schemas.openxmlformats.org/drawingml/2006/main">
             <a:fillRect l="0" t="0" r="0" b="0"/>
           </a:stretch>
@@ -13335,14 +13370,14 @@
       </p:sp>
       <p:pic>
         <p:nvPicPr>
-          <p:cNvPr id="94" name="图片 4"/>
+          <p:cNvPr id="138" name="图片 4"/>
           <p:cNvPicPr>
             <a:picLocks xmlns:a="http://schemas.openxmlformats.org/drawingml/2006/main" noChangeAspect="1"/>
           </p:cNvPicPr>
           <p:nvPr/>
         </p:nvPicPr>
         <p:blipFill>
-          <a:blip xmlns:r="http://schemas.openxmlformats.org/officeDocument/2006/relationships" xmlns:a="http://schemas.openxmlformats.org/drawingml/2006/main" r:embed="R8d1ae0c944ce41eb"/>
+          <a:blip xmlns:r="http://schemas.openxmlformats.org/officeDocument/2006/relationships" xmlns:a="http://schemas.openxmlformats.org/drawingml/2006/main" r:embed="R9a228043175849ad"/>
           <a:stretch xmlns:a="http://schemas.openxmlformats.org/drawingml/2006/main">
             <a:fillRect l="0" t="0" r="0" b="0"/>
           </a:stretch>
@@ -14563,7 +14598,7 @@
       </p:sp>
       <p:cxnSp>
         <p:nvCxnSpPr>
-          <p:cNvPr id="111" name="直接箭头连接符 50"/>
+          <p:cNvPr id="155" name="直接箭头连接符 50"/>
           <p:cNvCxnSpPr>
             <a:stCxn xmlns:a="http://schemas.openxmlformats.org/drawingml/2006/main" id="49" idx="3"/>
             <a:endCxn xmlns:a="http://schemas.openxmlformats.org/drawingml/2006/main" id="47" idx="1"/>
@@ -14599,7 +14634,7 @@
       </p:cxnSp>
       <p:cxnSp>
         <p:nvCxnSpPr>
-          <p:cNvPr id="112" name="直接箭头连接符 54"/>
+          <p:cNvPr id="156" name="直接箭头连接符 54"/>
           <p:cNvCxnSpPr/>
           <p:nvPr/>
         </p:nvCxnSpPr>
@@ -14632,7 +14667,7 @@
       </p:cxnSp>
       <p:cxnSp>
         <p:nvCxnSpPr>
-          <p:cNvPr id="113" name="直接箭头连接符 56"/>
+          <p:cNvPr id="157" name="直接箭头连接符 56"/>
           <p:cNvCxnSpPr/>
           <p:nvPr/>
         </p:nvCxnSpPr>
@@ -15444,7 +15479,7 @@
           <p:nvPr/>
         </p:nvPicPr>
         <p:blipFill>
-          <a:blip xmlns:r="http://schemas.openxmlformats.org/officeDocument/2006/relationships" xmlns:a="http://schemas.openxmlformats.org/drawingml/2006/main" r:embed="R366830f154144a77"/>
+          <a:blip xmlns:r="http://schemas.openxmlformats.org/officeDocument/2006/relationships" xmlns:a="http://schemas.openxmlformats.org/drawingml/2006/main" r:embed="R59b7d373edb8456f"/>
           <a:stretch xmlns:a="http://schemas.openxmlformats.org/drawingml/2006/main">
             <a:fillRect l="0" t="0" r="0" b="0"/>
           </a:stretch>
@@ -16505,7 +16540,7 @@
           <p:nvPr/>
         </p:nvPicPr>
         <p:blipFill>
-          <a:blip xmlns:r="http://schemas.openxmlformats.org/officeDocument/2006/relationships" xmlns:a="http://schemas.openxmlformats.org/drawingml/2006/main" r:embed="R3b51fcb2173d4830"/>
+          <a:blip xmlns:r="http://schemas.openxmlformats.org/officeDocument/2006/relationships" xmlns:a="http://schemas.openxmlformats.org/drawingml/2006/main" r:embed="R6735b17ded5f4799"/>
           <a:srcRect xmlns:a="http://schemas.openxmlformats.org/drawingml/2006/main" l="0" t="0" r="0" b="0"/>
           <a:stretch xmlns:a="http://schemas.openxmlformats.org/drawingml/2006/main">
             <a:fillRect l="0" t="0" r="0" b="0"/>
@@ -16952,7 +16987,7 @@
           <p:nvPr/>
         </p:nvPicPr>
         <p:blipFill>
-          <a:blip xmlns:r="http://schemas.openxmlformats.org/officeDocument/2006/relationships" xmlns:a="http://schemas.openxmlformats.org/drawingml/2006/main" r:embed="Rc611d1d8d9974c47"/>
+          <a:blip xmlns:r="http://schemas.openxmlformats.org/officeDocument/2006/relationships" xmlns:a="http://schemas.openxmlformats.org/drawingml/2006/main" r:embed="R90876767c57a4313"/>
           <a:srcRect xmlns:a="http://schemas.openxmlformats.org/drawingml/2006/main" l="0" t="0" r="0" b="0"/>
           <a:stretch xmlns:a="http://schemas.openxmlformats.org/drawingml/2006/main">
             <a:fillRect l="0" t="0" r="0" b="0"/>
@@ -17271,7 +17306,7 @@
           <p:nvPr/>
         </p:nvPicPr>
         <p:blipFill>
-          <a:blip xmlns:r="http://schemas.openxmlformats.org/officeDocument/2006/relationships" xmlns:a="http://schemas.openxmlformats.org/drawingml/2006/main" r:embed="Rbcbae47d75874d46"/>
+          <a:blip xmlns:r="http://schemas.openxmlformats.org/officeDocument/2006/relationships" xmlns:a="http://schemas.openxmlformats.org/drawingml/2006/main" r:embed="R634e877f120544fb"/>
           <a:srcRect xmlns:a="http://schemas.openxmlformats.org/drawingml/2006/main" l="0" t="0" r="0" b="0"/>
           <a:stretch xmlns:a="http://schemas.openxmlformats.org/drawingml/2006/main">
             <a:fillRect l="0" t="0" r="0" b="0"/>
@@ -17386,14 +17421,14 @@
       </p:sp>
       <p:pic>
         <p:nvPicPr>
-          <p:cNvPr id="33" name="图片 4"/>
+          <p:cNvPr id="36" name="图片 4"/>
           <p:cNvPicPr>
             <a:picLocks xmlns:a="http://schemas.openxmlformats.org/drawingml/2006/main" noChangeAspect="1"/>
           </p:cNvPicPr>
           <p:nvPr/>
         </p:nvPicPr>
         <p:blipFill>
-          <a:blip xmlns:r="http://schemas.openxmlformats.org/officeDocument/2006/relationships" xmlns:a="http://schemas.openxmlformats.org/drawingml/2006/main" r:embed="R31674843f5544c5c"/>
+          <a:blip xmlns:r="http://schemas.openxmlformats.org/officeDocument/2006/relationships" xmlns:a="http://schemas.openxmlformats.org/drawingml/2006/main" r:embed="R377bd34b27c34022"/>
           <a:stretch xmlns:a="http://schemas.openxmlformats.org/drawingml/2006/main">
             <a:fillRect l="0" t="0" r="0" b="0"/>
           </a:stretch>
@@ -18305,7 +18340,7 @@
       </p:sp>
       <p:graphicFrame>
         <p:nvGraphicFramePr>
-          <p:cNvPr id="45" name="Chart"/>
+          <p:cNvPr id="48" name="Chart"/>
           <p:cNvGraphicFramePr/>
           <p:nvPr/>
         </p:nvGraphicFramePr>
@@ -18315,13 +18350,13 @@
         </p:xfrm>
         <a:graphic xmlns:a="http://schemas.openxmlformats.org/drawingml/2006/main">
           <a:graphicData uri="http://schemas.openxmlformats.org/drawingml/2006/chart">
-            <c:chart xmlns:r="http://schemas.openxmlformats.org/officeDocument/2006/relationships" xmlns:c="http://schemas.openxmlformats.org/drawingml/2006/chart" r:id="R0d420c6146a44b46"/>
+            <c:chart xmlns:r="http://schemas.openxmlformats.org/officeDocument/2006/relationships" xmlns:c="http://schemas.openxmlformats.org/drawingml/2006/chart" r:id="Rb5426df5ed7b4b90"/>
           </a:graphicData>
         </a:graphic>
       </p:graphicFrame>
       <p:graphicFrame>
         <p:nvGraphicFramePr>
-          <p:cNvPr id="46" name="Chart"/>
+          <p:cNvPr id="49" name="Chart"/>
           <p:cNvGraphicFramePr/>
           <p:nvPr/>
         </p:nvGraphicFramePr>
@@ -18331,7 +18366,7 @@
         </p:xfrm>
         <a:graphic xmlns:a="http://schemas.openxmlformats.org/drawingml/2006/main">
           <a:graphicData uri="http://schemas.openxmlformats.org/drawingml/2006/chart">
-            <c:chart xmlns:r="http://schemas.openxmlformats.org/officeDocument/2006/relationships" xmlns:c="http://schemas.openxmlformats.org/drawingml/2006/chart" r:id="Rf50086a33b1346d0"/>
+            <c:chart xmlns:r="http://schemas.openxmlformats.org/officeDocument/2006/relationships" xmlns:c="http://schemas.openxmlformats.org/drawingml/2006/chart" r:id="Rd5a435d533a14c43"/>
           </a:graphicData>
         </a:graphic>
       </p:graphicFrame>
@@ -18372,6 +18407,7 @@
           <a:lstStyle xmlns:a="http://schemas.openxmlformats.org/drawingml/2006/main"/>
           <a:p xmlns:a="http://schemas.openxmlformats.org/drawingml/2006/main">
             <a:pPr algn="ctr">
+              <a:buNone/>
               <a:defRPr sz="1500" b="1">
                 <a:solidFill>
                   <a:srgbClr val="2F5597"/>
@@ -18395,6 +18431,7 @@
           </a:p>
           <a:p xmlns:a="http://schemas.openxmlformats.org/drawingml/2006/main">
             <a:pPr algn="ctr">
+              <a:buNone/>
               <a:defRPr sz="1500" b="1">
                 <a:solidFill>
                   <a:srgbClr val="2F5597"/>
@@ -18423,6 +18460,7 @@
           </a:p>
           <a:p xmlns:a="http://schemas.openxmlformats.org/drawingml/2006/main">
             <a:pPr algn="ctr">
+              <a:buNone/>
               <a:defRPr sz="1500" b="1">
                 <a:solidFill>
                   <a:srgbClr val="2F5597"/>
@@ -18446,6 +18484,7 @@
           </a:p>
           <a:p xmlns:a="http://schemas.openxmlformats.org/drawingml/2006/main">
             <a:pPr algn="ctr">
+              <a:buNone/>
               <a:defRPr sz="1500" b="1">
                 <a:solidFill>
                   <a:srgbClr val="2F5597"/>
@@ -18474,6 +18513,7 @@
           </a:p>
           <a:p xmlns:a="http://schemas.openxmlformats.org/drawingml/2006/main">
             <a:pPr algn="ctr">
+              <a:buNone/>
               <a:defRPr sz="1500" b="1">
                 <a:solidFill>
                   <a:srgbClr val="2F5597"/>
@@ -18596,14 +18636,14 @@
       </p:sp>
       <p:pic>
         <p:nvPicPr>
-          <p:cNvPr id="159" name="图片 4"/>
+          <p:cNvPr id="285" name="图片 4"/>
           <p:cNvPicPr>
             <a:picLocks xmlns:a="http://schemas.openxmlformats.org/drawingml/2006/main" noChangeAspect="1"/>
           </p:cNvPicPr>
           <p:nvPr/>
         </p:nvPicPr>
         <p:blipFill>
-          <a:blip xmlns:r="http://schemas.openxmlformats.org/officeDocument/2006/relationships" xmlns:a="http://schemas.openxmlformats.org/drawingml/2006/main" r:embed="R3c49cfd670394557"/>
+          <a:blip xmlns:r="http://schemas.openxmlformats.org/officeDocument/2006/relationships" xmlns:a="http://schemas.openxmlformats.org/drawingml/2006/main" r:embed="Rb6b4c6ed36fb48e9"/>
           <a:stretch xmlns:a="http://schemas.openxmlformats.org/drawingml/2006/main">
             <a:fillRect l="0" t="0" r="0" b="0"/>
           </a:stretch>
@@ -19177,14 +19217,14 @@
       </p:sp>
       <p:pic>
         <p:nvPicPr>
-          <p:cNvPr id="167" name="图片 9"/>
+          <p:cNvPr id="293" name="图片 9"/>
           <p:cNvPicPr>
             <a:picLocks xmlns:a="http://schemas.openxmlformats.org/drawingml/2006/main" noChangeAspect="1"/>
           </p:cNvPicPr>
           <p:nvPr/>
         </p:nvPicPr>
         <p:blipFill>
-          <a:blip xmlns:r="http://schemas.openxmlformats.org/officeDocument/2006/relationships" xmlns:a="http://schemas.openxmlformats.org/drawingml/2006/main" r:embed="R1bdad5bdc0754b02"/>
+          <a:blip xmlns:r="http://schemas.openxmlformats.org/officeDocument/2006/relationships" xmlns:a="http://schemas.openxmlformats.org/drawingml/2006/main" r:embed="R4a297d1e5b034458"/>
           <a:stretch xmlns:a="http://schemas.openxmlformats.org/drawingml/2006/main">
             <a:fillRect l="0" t="0" r="0" b="0"/>
           </a:stretch>
@@ -19251,7 +19291,7 @@
       </p:sp>
       <p:cxnSp>
         <p:nvCxnSpPr>
-          <p:cNvPr id="169" name="直接箭头连接符 17"/>
+          <p:cNvPr id="295" name="直接箭头连接符 17"/>
           <p:cNvCxnSpPr>
             <a:endCxn xmlns:a="http://schemas.openxmlformats.org/drawingml/2006/main" id="16" idx="3"/>
           </p:cNvCxnSpPr>
@@ -19448,14 +19488,14 @@
       </p:sp>
       <p:pic>
         <p:nvPicPr>
-          <p:cNvPr id="172" name="图片 25"/>
+          <p:cNvPr id="298" name="图片 25"/>
           <p:cNvPicPr>
             <a:picLocks xmlns:a="http://schemas.openxmlformats.org/drawingml/2006/main" noChangeAspect="1"/>
           </p:cNvPicPr>
           <p:nvPr/>
         </p:nvPicPr>
         <p:blipFill>
-          <a:blip xmlns:r="http://schemas.openxmlformats.org/officeDocument/2006/relationships" xmlns:a="http://schemas.openxmlformats.org/drawingml/2006/main" r:embed="R1bdad5bdc0754b02"/>
+          <a:blip xmlns:r="http://schemas.openxmlformats.org/officeDocument/2006/relationships" xmlns:a="http://schemas.openxmlformats.org/drawingml/2006/main" r:embed="R4a297d1e5b034458"/>
           <a:stretch xmlns:a="http://schemas.openxmlformats.org/drawingml/2006/main">
             <a:fillRect l="0" t="0" r="0" b="0"/>
           </a:stretch>
@@ -19909,14 +19949,14 @@
       </p:sp>
       <p:pic>
         <p:nvPicPr>
-          <p:cNvPr id="181" name="图片 52"/>
+          <p:cNvPr id="307" name="图片 52"/>
           <p:cNvPicPr>
             <a:picLocks xmlns:a="http://schemas.openxmlformats.org/drawingml/2006/main" noChangeAspect="1"/>
           </p:cNvPicPr>
           <p:nvPr/>
         </p:nvPicPr>
         <p:blipFill>
-          <a:blip xmlns:r="http://schemas.openxmlformats.org/officeDocument/2006/relationships" xmlns:a="http://schemas.openxmlformats.org/drawingml/2006/main" r:embed="R1bdad5bdc0754b02"/>
+          <a:blip xmlns:r="http://schemas.openxmlformats.org/officeDocument/2006/relationships" xmlns:a="http://schemas.openxmlformats.org/drawingml/2006/main" r:embed="R4a297d1e5b034458"/>
           <a:stretch xmlns:a="http://schemas.openxmlformats.org/drawingml/2006/main">
             <a:fillRect l="0" t="0" r="0" b="0"/>
           </a:stretch>
@@ -20506,14 +20546,14 @@
       </p:sp>
       <p:pic>
         <p:nvPicPr>
-          <p:cNvPr id="192" name="图片 2"/>
+          <p:cNvPr id="318" name="图片 2"/>
           <p:cNvPicPr>
             <a:picLocks xmlns:a="http://schemas.openxmlformats.org/drawingml/2006/main" noChangeAspect="1"/>
           </p:cNvPicPr>
           <p:nvPr/>
         </p:nvPicPr>
         <p:blipFill>
-          <a:blip xmlns:r="http://schemas.openxmlformats.org/officeDocument/2006/relationships" xmlns:a="http://schemas.openxmlformats.org/drawingml/2006/main" r:embed="R83a0ecfa937c4d14"/>
+          <a:blip xmlns:r="http://schemas.openxmlformats.org/officeDocument/2006/relationships" xmlns:a="http://schemas.openxmlformats.org/drawingml/2006/main" r:embed="Re43b6787ef214aab"/>
           <a:srcRect xmlns:a="http://schemas.openxmlformats.org/drawingml/2006/main" l="0" t="0" r="0" b="0"/>
           <a:stretch xmlns:a="http://schemas.openxmlformats.org/drawingml/2006/main">
             <a:fillRect l="0" t="0" r="0" b="0"/>
@@ -20608,14 +20648,14 @@
       </p:sp>
       <p:pic>
         <p:nvPicPr>
-          <p:cNvPr id="194" name="图片 7"/>
+          <p:cNvPr id="320" name="图片 7"/>
           <p:cNvPicPr>
             <a:picLocks xmlns:a="http://schemas.openxmlformats.org/drawingml/2006/main" noChangeAspect="1"/>
           </p:cNvPicPr>
           <p:nvPr/>
         </p:nvPicPr>
         <p:blipFill>
-          <a:blip xmlns:r="http://schemas.openxmlformats.org/officeDocument/2006/relationships" xmlns:a="http://schemas.openxmlformats.org/drawingml/2006/main" r:embed="R1bdad5bdc0754b02"/>
+          <a:blip xmlns:r="http://schemas.openxmlformats.org/officeDocument/2006/relationships" xmlns:a="http://schemas.openxmlformats.org/drawingml/2006/main" r:embed="R4a297d1e5b034458"/>
           <a:stretch xmlns:a="http://schemas.openxmlformats.org/drawingml/2006/main">
             <a:fillRect l="0" t="0" r="0" b="0"/>
           </a:stretch>
@@ -20882,7 +20922,7 @@
       </p:sp>
       <p:cxnSp>
         <p:nvCxnSpPr>
-          <p:cNvPr id="200" name="直接箭头连接符 46"/>
+          <p:cNvPr id="326" name="直接箭头连接符 46"/>
           <p:cNvCxnSpPr>
             <a:stCxn xmlns:a="http://schemas.openxmlformats.org/drawingml/2006/main" id="46" idx="5"/>
           </p:cNvCxnSpPr>
@@ -20923,7 +20963,7 @@
       </p:cxnSp>
       <p:cxnSp>
         <p:nvCxnSpPr>
-          <p:cNvPr id="201" name="直接箭头连接符 47"/>
+          <p:cNvPr id="327" name="直接箭头连接符 47"/>
           <p:cNvCxnSpPr/>
           <p:nvPr/>
         </p:nvCxnSpPr>
@@ -20962,7 +21002,7 @@
       </p:cxnSp>
       <p:cxnSp>
         <p:nvCxnSpPr>
-          <p:cNvPr id="202" name="直接箭头连接符 48"/>
+          <p:cNvPr id="328" name="直接箭头连接符 48"/>
           <p:cNvCxnSpPr/>
           <p:nvPr/>
         </p:nvCxnSpPr>
@@ -21001,7 +21041,7 @@
       </p:cxnSp>
       <p:cxnSp>
         <p:nvCxnSpPr>
-          <p:cNvPr id="203" name="直接箭头连接符 49"/>
+          <p:cNvPr id="329" name="直接箭头连接符 49"/>
           <p:cNvCxnSpPr>
             <a:stCxn xmlns:a="http://schemas.openxmlformats.org/drawingml/2006/main" id="45" idx="1"/>
           </p:cNvCxnSpPr>
@@ -21042,14 +21082,14 @@
       </p:cxnSp>
       <p:pic>
         <p:nvPicPr>
-          <p:cNvPr id="204" name="图片 75"/>
+          <p:cNvPr id="330" name="图片 75"/>
           <p:cNvPicPr>
             <a:picLocks xmlns:a="http://schemas.openxmlformats.org/drawingml/2006/main" noChangeAspect="1"/>
           </p:cNvPicPr>
           <p:nvPr/>
         </p:nvPicPr>
         <p:blipFill>
-          <a:blip xmlns:r="http://schemas.openxmlformats.org/officeDocument/2006/relationships" xmlns:a="http://schemas.openxmlformats.org/drawingml/2006/main" r:embed="R1bdad5bdc0754b02"/>
+          <a:blip xmlns:r="http://schemas.openxmlformats.org/officeDocument/2006/relationships" xmlns:a="http://schemas.openxmlformats.org/drawingml/2006/main" r:embed="R4a297d1e5b034458"/>
           <a:stretch xmlns:a="http://schemas.openxmlformats.org/drawingml/2006/main">
             <a:fillRect l="0" t="0" r="0" b="0"/>
           </a:stretch>
@@ -21353,7 +21393,7 @@
       </p:sp>
       <p:cxnSp>
         <p:nvCxnSpPr>
-          <p:cNvPr id="210" name="直接箭头连接符 81"/>
+          <p:cNvPr id="336" name="直接箭头连接符 81"/>
           <p:cNvCxnSpPr>
             <a:stCxn xmlns:a="http://schemas.openxmlformats.org/drawingml/2006/main" id="81" idx="5"/>
           </p:cNvCxnSpPr>
@@ -21394,7 +21434,7 @@
       </p:cxnSp>
       <p:cxnSp>
         <p:nvCxnSpPr>
-          <p:cNvPr id="211" name="直接箭头连接符 82"/>
+          <p:cNvPr id="337" name="直接箭头连接符 82"/>
           <p:cNvCxnSpPr/>
           <p:nvPr/>
         </p:nvCxnSpPr>
@@ -21433,7 +21473,7 @@
       </p:cxnSp>
       <p:cxnSp>
         <p:nvCxnSpPr>
-          <p:cNvPr id="212" name="直接箭头连接符 83"/>
+          <p:cNvPr id="338" name="直接箭头连接符 83"/>
           <p:cNvCxnSpPr/>
           <p:nvPr/>
         </p:nvCxnSpPr>
@@ -21472,7 +21512,7 @@
       </p:cxnSp>
       <p:cxnSp>
         <p:nvCxnSpPr>
-          <p:cNvPr id="213" name="直接箭头连接符 84"/>
+          <p:cNvPr id="339" name="直接箭头连接符 84"/>
           <p:cNvCxnSpPr>
             <a:stCxn xmlns:a="http://schemas.openxmlformats.org/drawingml/2006/main" id="80" idx="1"/>
           </p:cNvCxnSpPr>
@@ -21729,7 +21769,7 @@
           <p:nvPr/>
         </p:nvPicPr>
         <p:blipFill>
-          <a:blip xmlns:r="http://schemas.openxmlformats.org/officeDocument/2006/relationships" xmlns:a="http://schemas.openxmlformats.org/drawingml/2006/main" r:embed="R95e2459c3c994c28"/>
+          <a:blip xmlns:r="http://schemas.openxmlformats.org/officeDocument/2006/relationships" xmlns:a="http://schemas.openxmlformats.org/drawingml/2006/main" r:embed="R84a5bb5766b84db6"/>
           <a:stretch xmlns:a="http://schemas.openxmlformats.org/drawingml/2006/main">
             <a:fillRect l="0" t="0" r="0" b="0"/>
           </a:stretch>
@@ -22294,7 +22334,7 @@
         </p:xfrm>
         <a:graphic xmlns:a="http://schemas.openxmlformats.org/drawingml/2006/main">
           <a:graphicData uri="http://schemas.openxmlformats.org/drawingml/2006/chart">
-            <c:chart xmlns:r="http://schemas.openxmlformats.org/officeDocument/2006/relationships" xmlns:c="http://schemas.openxmlformats.org/drawingml/2006/chart" r:id="Rd6cd2312d9ca4e5a"/>
+            <c:chart xmlns:r="http://schemas.openxmlformats.org/officeDocument/2006/relationships" xmlns:c="http://schemas.openxmlformats.org/drawingml/2006/chart" r:id="Rf78916598e774319"/>
           </a:graphicData>
         </a:graphic>
       </p:graphicFrame>
@@ -22723,14 +22763,14 @@
       </p:sp>
       <p:pic>
         <p:nvPicPr>
-          <p:cNvPr id="94" name="图片 4"/>
+          <p:cNvPr id="138" name="图片 4"/>
           <p:cNvPicPr>
             <a:picLocks xmlns:a="http://schemas.openxmlformats.org/drawingml/2006/main" noChangeAspect="1"/>
           </p:cNvPicPr>
           <p:nvPr/>
         </p:nvPicPr>
         <p:blipFill>
-          <a:blip xmlns:r="http://schemas.openxmlformats.org/officeDocument/2006/relationships" xmlns:a="http://schemas.openxmlformats.org/drawingml/2006/main" r:embed="R4259a4c692fd42a0"/>
+          <a:blip xmlns:r="http://schemas.openxmlformats.org/officeDocument/2006/relationships" xmlns:a="http://schemas.openxmlformats.org/drawingml/2006/main" r:embed="R684951fe3dd9413a"/>
           <a:stretch xmlns:a="http://schemas.openxmlformats.org/drawingml/2006/main">
             <a:fillRect l="0" t="0" r="0" b="0"/>
           </a:stretch>
@@ -23951,7 +23991,7 @@
       </p:sp>
       <p:cxnSp>
         <p:nvCxnSpPr>
-          <p:cNvPr id="111" name="直接箭头连接符 50"/>
+          <p:cNvPr id="155" name="直接箭头连接符 50"/>
           <p:cNvCxnSpPr>
             <a:stCxn xmlns:a="http://schemas.openxmlformats.org/drawingml/2006/main" id="49" idx="3"/>
             <a:endCxn xmlns:a="http://schemas.openxmlformats.org/drawingml/2006/main" id="47" idx="1"/>
@@ -23987,7 +24027,7 @@
       </p:cxnSp>
       <p:cxnSp>
         <p:nvCxnSpPr>
-          <p:cNvPr id="112" name="直接箭头连接符 54"/>
+          <p:cNvPr id="156" name="直接箭头连接符 54"/>
           <p:cNvCxnSpPr/>
           <p:nvPr/>
         </p:nvCxnSpPr>
@@ -24020,7 +24060,7 @@
       </p:cxnSp>
       <p:cxnSp>
         <p:nvCxnSpPr>
-          <p:cNvPr id="113" name="直接箭头连接符 56"/>
+          <p:cNvPr id="157" name="直接箭头连接符 56"/>
           <p:cNvCxnSpPr/>
           <p:nvPr/>
         </p:nvCxnSpPr>

</xml_diff>